<commit_message>
Sync Sports Economics eb12761
</commit_message>
<xml_diff>
--- a/sports-econ/downloads/chapter-1-introduction-to-sports-economics.pptx
+++ b/sports-econ/downloads/chapter-1-introduction-to-sports-economics.pptx
@@ -2,28 +2,28 @@
 <file path=ppt/presentation.xml><?xml version="1.0" encoding="utf-8"?>
 <p:presentation xmlns:p="http://schemas.openxmlformats.org/presentationml/2006/main">
   <p:sldMasterIdLst>
-    <p:sldMasterId xmlns:r="http://schemas.openxmlformats.org/officeDocument/2006/relationships" id="2147483648" r:id="R75f35bf75e4646b1"/>
+    <p:sldMasterId xmlns:r="http://schemas.openxmlformats.org/officeDocument/2006/relationships" id="2147483648" r:id="Rf1aaa738e9a24f27"/>
   </p:sldMasterIdLst>
   <p:notesMasterIdLst>
-    <p:notesMasterId xmlns:r="http://schemas.openxmlformats.org/officeDocument/2006/relationships" r:id="R50a68211d0094312"/>
+    <p:notesMasterId xmlns:r="http://schemas.openxmlformats.org/officeDocument/2006/relationships" r:id="Rd3a515d4ab394df5"/>
   </p:notesMasterIdLst>
   <p:sldIdLst>
-    <p:sldId xmlns:r="http://schemas.openxmlformats.org/officeDocument/2006/relationships" id="256" r:id="Rda4b900565a74194"/>
-    <p:sldId xmlns:r="http://schemas.openxmlformats.org/officeDocument/2006/relationships" id="257" r:id="R3ee6f19b5f0940e8"/>
-    <p:sldId xmlns:r="http://schemas.openxmlformats.org/officeDocument/2006/relationships" id="258" r:id="R8b94d83821a24ca1"/>
-    <p:sldId xmlns:r="http://schemas.openxmlformats.org/officeDocument/2006/relationships" id="259" r:id="Rac022695a6e6406b"/>
-    <p:sldId xmlns:r="http://schemas.openxmlformats.org/officeDocument/2006/relationships" id="260" r:id="R2095eff044de44bb"/>
-    <p:sldId xmlns:r="http://schemas.openxmlformats.org/officeDocument/2006/relationships" id="261" r:id="Rddbd2b8305174561"/>
-    <p:sldId xmlns:r="http://schemas.openxmlformats.org/officeDocument/2006/relationships" id="262" r:id="Ra7dab38c86d84114"/>
-    <p:sldId xmlns:r="http://schemas.openxmlformats.org/officeDocument/2006/relationships" id="263" r:id="R391547ca08cd439d"/>
-    <p:sldId xmlns:r="http://schemas.openxmlformats.org/officeDocument/2006/relationships" id="264" r:id="R4a3e83a62ae24187"/>
-    <p:sldId xmlns:r="http://schemas.openxmlformats.org/officeDocument/2006/relationships" id="265" r:id="R2e3017e742f640b8"/>
-    <p:sldId xmlns:r="http://schemas.openxmlformats.org/officeDocument/2006/relationships" id="266" r:id="R654c33ebe9ff43f2"/>
-    <p:sldId xmlns:r="http://schemas.openxmlformats.org/officeDocument/2006/relationships" id="267" r:id="R32161b88424745c5"/>
-    <p:sldId xmlns:r="http://schemas.openxmlformats.org/officeDocument/2006/relationships" id="268" r:id="R2b72f5fafa4b4a0e"/>
-    <p:sldId xmlns:r="http://schemas.openxmlformats.org/officeDocument/2006/relationships" id="269" r:id="R42e065f932764541"/>
-    <p:sldId xmlns:r="http://schemas.openxmlformats.org/officeDocument/2006/relationships" id="270" r:id="R60a5d417b7724d98"/>
-    <p:sldId xmlns:r="http://schemas.openxmlformats.org/officeDocument/2006/relationships" id="271" r:id="R62fc683c0c834d4f"/>
+    <p:sldId xmlns:r="http://schemas.openxmlformats.org/officeDocument/2006/relationships" id="256" r:id="Rd1de90bbd40b45b1"/>
+    <p:sldId xmlns:r="http://schemas.openxmlformats.org/officeDocument/2006/relationships" id="257" r:id="R7df55c9edfc3442e"/>
+    <p:sldId xmlns:r="http://schemas.openxmlformats.org/officeDocument/2006/relationships" id="258" r:id="R9ced585f2e084883"/>
+    <p:sldId xmlns:r="http://schemas.openxmlformats.org/officeDocument/2006/relationships" id="259" r:id="R1bdfcf41b4ae4778"/>
+    <p:sldId xmlns:r="http://schemas.openxmlformats.org/officeDocument/2006/relationships" id="260" r:id="R29be336104464cbc"/>
+    <p:sldId xmlns:r="http://schemas.openxmlformats.org/officeDocument/2006/relationships" id="261" r:id="Rc0fa2f4280244968"/>
+    <p:sldId xmlns:r="http://schemas.openxmlformats.org/officeDocument/2006/relationships" id="262" r:id="R243ffa88e1a04042"/>
+    <p:sldId xmlns:r="http://schemas.openxmlformats.org/officeDocument/2006/relationships" id="263" r:id="R113622620d8c4e76"/>
+    <p:sldId xmlns:r="http://schemas.openxmlformats.org/officeDocument/2006/relationships" id="264" r:id="Refd9d700e0a744cb"/>
+    <p:sldId xmlns:r="http://schemas.openxmlformats.org/officeDocument/2006/relationships" id="265" r:id="R9dfc4216b8114012"/>
+    <p:sldId xmlns:r="http://schemas.openxmlformats.org/officeDocument/2006/relationships" id="266" r:id="Rba510e9b62424744"/>
+    <p:sldId xmlns:r="http://schemas.openxmlformats.org/officeDocument/2006/relationships" id="267" r:id="R7a0795f8446849bd"/>
+    <p:sldId xmlns:r="http://schemas.openxmlformats.org/officeDocument/2006/relationships" id="268" r:id="R2e2ecde3712f46b4"/>
+    <p:sldId xmlns:r="http://schemas.openxmlformats.org/officeDocument/2006/relationships" id="269" r:id="R9c7784cfd8bd4dbc"/>
+    <p:sldId xmlns:r="http://schemas.openxmlformats.org/officeDocument/2006/relationships" id="270" r:id="Rd01b3e00c6a14c38"/>
+    <p:sldId xmlns:r="http://schemas.openxmlformats.org/officeDocument/2006/relationships" id="271" r:id="R336f263d79004acb"/>
   </p:sldIdLst>
   <p:sldSz cx="12192000" cy="6858000"/>
   <p:notesSz cx="6858000" cy="9144000"/>
@@ -1915,7 +1915,7 @@
   </p:cSld>
   <p:clrMap bg1="lt1" tx1="dk1" bg2="lt2" tx2="dk2" accent1="accent1" accent2="accent2" accent3="accent3" accent4="accent4" accent5="accent5" accent6="accent6" hlink="hlink" folHlink="folHlink"/>
   <p:sldLayoutIdLst>
-    <p:sldLayoutId xmlns:r="http://schemas.openxmlformats.org/officeDocument/2006/relationships" id="2147483649" r:id="Rfa17d6aa01674d6a"/>
+    <p:sldLayoutId xmlns:r="http://schemas.openxmlformats.org/officeDocument/2006/relationships" id="2147483649" r:id="R441ba55d334b42c6"/>
   </p:sldLayoutIdLst>
   <p:txStyles>
     <p:titleStyle>
@@ -2466,7 +2466,7 @@
           <p:cNvPr id="6" name="deck-supertitle">
             <a:extLst xmlns:a="http://schemas.openxmlformats.org/drawingml/2006/main">
               <a:ext uri="{FF2B5EF4-FFF2-40B4-BE49-F238E27FC236}">
-                <a16:creationId xmlns:a16="http://schemas.microsoft.com/office/drawing/2014/main" id="{3768405C-E07F-4B3F-A31A-A46588A9E856}"/>
+                <a16:creationId xmlns:a16="http://schemas.microsoft.com/office/drawing/2014/main" id="{7FC9C094-3054-4422-95AB-6C848C3F929D}"/>
               </a:ext>
             </a:extLst>
           </p:cNvPr>
@@ -2528,7 +2528,7 @@
           <p:cNvPr id="2" name="deck-title">
             <a:extLst xmlns:a="http://schemas.openxmlformats.org/drawingml/2006/main">
               <a:ext uri="{FF2B5EF4-FFF2-40B4-BE49-F238E27FC236}">
-                <a16:creationId xmlns:a16="http://schemas.microsoft.com/office/drawing/2014/main" id="{DBDDAC9C-7CEF-4225-B74D-FBCC1FF05AB7}"/>
+                <a16:creationId xmlns:a16="http://schemas.microsoft.com/office/drawing/2014/main" id="{94338AAE-0468-4A29-ADDB-FDAA3C7B5E34}"/>
               </a:ext>
             </a:extLst>
           </p:cNvPr>
@@ -2590,7 +2590,7 @@
           <p:cNvPr id="3" name="deck-subtitle">
             <a:extLst xmlns:a="http://schemas.openxmlformats.org/drawingml/2006/main">
               <a:ext uri="{FF2B5EF4-FFF2-40B4-BE49-F238E27FC236}">
-                <a16:creationId xmlns:a16="http://schemas.microsoft.com/office/drawing/2014/main" id="{3F632685-9984-4B24-9E46-2ACAF70BBFD7}"/>
+                <a16:creationId xmlns:a16="http://schemas.microsoft.com/office/drawing/2014/main" id="{B9F29EDF-AEDA-42D4-AA22-EC066583E020}"/>
               </a:ext>
             </a:extLst>
           </p:cNvPr>
@@ -2652,7 +2652,7 @@
           <p:cNvPr id="4" name="title-field">
             <a:extLst xmlns:a="http://schemas.openxmlformats.org/drawingml/2006/main">
               <a:ext uri="{FF2B5EF4-FFF2-40B4-BE49-F238E27FC236}">
-                <a16:creationId xmlns:a16="http://schemas.microsoft.com/office/drawing/2014/main" id="{9DC30D00-7FC0-41E6-9904-2119B0A390B8}"/>
+                <a16:creationId xmlns:a16="http://schemas.microsoft.com/office/drawing/2014/main" id="{1FA76D3A-4E76-4B0B-BFA9-7EC68DE468C6}"/>
               </a:ext>
             </a:extLst>
           </p:cNvPr>
@@ -2683,7 +2683,7 @@
           <p:cNvPr id="5" name="deck-number">
             <a:extLst xmlns:a="http://schemas.openxmlformats.org/drawingml/2006/main">
               <a:ext uri="{FF2B5EF4-FFF2-40B4-BE49-F238E27FC236}">
-                <a16:creationId xmlns:a16="http://schemas.microsoft.com/office/drawing/2014/main" id="{3B4D6A46-3BA1-449A-BB55-759A148FD197}"/>
+                <a16:creationId xmlns:a16="http://schemas.microsoft.com/office/drawing/2014/main" id="{7D1E83A0-15AC-4970-8D39-03E0ECEA2A99}"/>
               </a:ext>
             </a:extLst>
           </p:cNvPr>
@@ -2743,7 +2743,7 @@
     </p:spTree>
     <p:extLst>
       <p:ext uri="{BB962C8B-B14F-4D97-AF65-F5344CB8AC3E}">
-        <p14:creationId xmlns:p14="http://schemas.microsoft.com/office/powerpoint/2010/main" val="1447666618"/>
+        <p14:creationId xmlns:p14="http://schemas.microsoft.com/office/powerpoint/2010/main" val="2103729455"/>
       </p:ext>
     </p:extLst>
   </p:cSld>
@@ -2774,7 +2774,7 @@
           <p:cNvPr id="17" name="chapter-label">
             <a:extLst xmlns:a="http://schemas.openxmlformats.org/drawingml/2006/main">
               <a:ext uri="{FF2B5EF4-FFF2-40B4-BE49-F238E27FC236}">
-                <a16:creationId xmlns:a16="http://schemas.microsoft.com/office/drawing/2014/main" id="{A2991059-0F84-4C3A-8804-7AD16DE847B8}"/>
+                <a16:creationId xmlns:a16="http://schemas.microsoft.com/office/drawing/2014/main" id="{DF9D7B84-FDE0-4170-AD08-D1525287FEEA}"/>
               </a:ext>
             </a:extLst>
           </p:cNvPr>
@@ -2836,7 +2836,7 @@
           <p:cNvPr id="2" name="slide-title">
             <a:extLst xmlns:a="http://schemas.openxmlformats.org/drawingml/2006/main">
               <a:ext uri="{FF2B5EF4-FFF2-40B4-BE49-F238E27FC236}">
-                <a16:creationId xmlns:a16="http://schemas.microsoft.com/office/drawing/2014/main" id="{3AB8CF00-C2F1-472B-BBE0-55D51C2323DB}"/>
+                <a16:creationId xmlns:a16="http://schemas.microsoft.com/office/drawing/2014/main" id="{E3446FA2-A785-4CF2-BF97-B2DB44AA9DF2}"/>
               </a:ext>
             </a:extLst>
           </p:cNvPr>
@@ -2898,7 +2898,7 @@
           <p:cNvPr id="3" name="footer-rule">
             <a:extLst xmlns:a="http://schemas.openxmlformats.org/drawingml/2006/main">
               <a:ext uri="{FF2B5EF4-FFF2-40B4-BE49-F238E27FC236}">
-                <a16:creationId xmlns:a16="http://schemas.microsoft.com/office/drawing/2014/main" id="{36B187C3-B02E-4E88-9042-24F14290DE49}"/>
+                <a16:creationId xmlns:a16="http://schemas.microsoft.com/office/drawing/2014/main" id="{6BD156D0-8B76-4A68-9999-B6EE767D070C}"/>
               </a:ext>
             </a:extLst>
           </p:cNvPr>
@@ -2929,7 +2929,7 @@
           <p:cNvPr id="4" name="footer-book">
             <a:extLst xmlns:a="http://schemas.openxmlformats.org/drawingml/2006/main">
               <a:ext uri="{FF2B5EF4-FFF2-40B4-BE49-F238E27FC236}">
-                <a16:creationId xmlns:a16="http://schemas.microsoft.com/office/drawing/2014/main" id="{A58DDDF3-476C-42B0-B262-977A720ED824}"/>
+                <a16:creationId xmlns:a16="http://schemas.microsoft.com/office/drawing/2014/main" id="{479CE9CC-D716-4E25-BAFB-FD7E3DE52FE7}"/>
               </a:ext>
             </a:extLst>
           </p:cNvPr>
@@ -2991,7 +2991,7 @@
           <p:cNvPr id="5" name="footer-number">
             <a:extLst xmlns:a="http://schemas.openxmlformats.org/drawingml/2006/main">
               <a:ext uri="{FF2B5EF4-FFF2-40B4-BE49-F238E27FC236}">
-                <a16:creationId xmlns:a16="http://schemas.microsoft.com/office/drawing/2014/main" id="{B4EE57D1-45AF-4C7F-A76F-7A960F7F976A}"/>
+                <a16:creationId xmlns:a16="http://schemas.microsoft.com/office/drawing/2014/main" id="{5A908F90-61FD-45DE-BC87-4B8237D6995B}"/>
               </a:ext>
             </a:extLst>
           </p:cNvPr>
@@ -3053,7 +3053,7 @@
           <p:cNvPr id="6" name="bullet-mark-1">
             <a:extLst xmlns:a="http://schemas.openxmlformats.org/drawingml/2006/main">
               <a:ext uri="{FF2B5EF4-FFF2-40B4-BE49-F238E27FC236}">
-                <a16:creationId xmlns:a16="http://schemas.microsoft.com/office/drawing/2014/main" id="{55FDB9FE-1D48-4AC5-8A9F-3D151FB4DB10}"/>
+                <a16:creationId xmlns:a16="http://schemas.microsoft.com/office/drawing/2014/main" id="{A3767223-02A6-4A72-ACF6-115703B4570E}"/>
               </a:ext>
             </a:extLst>
           </p:cNvPr>
@@ -3115,7 +3115,7 @@
           <p:cNvPr id="7" name="bullet-1">
             <a:extLst xmlns:a="http://schemas.openxmlformats.org/drawingml/2006/main">
               <a:ext uri="{FF2B5EF4-FFF2-40B4-BE49-F238E27FC236}">
-                <a16:creationId xmlns:a16="http://schemas.microsoft.com/office/drawing/2014/main" id="{01C43684-1761-4F5F-9948-94D6D22BE7A0}"/>
+                <a16:creationId xmlns:a16="http://schemas.microsoft.com/office/drawing/2014/main" id="{61E69FF0-0781-4513-B65F-13BC43BDDBB5}"/>
               </a:ext>
             </a:extLst>
           </p:cNvPr>
@@ -3177,7 +3177,7 @@
           <p:cNvPr id="8" name="bullet-mark-2">
             <a:extLst xmlns:a="http://schemas.openxmlformats.org/drawingml/2006/main">
               <a:ext uri="{FF2B5EF4-FFF2-40B4-BE49-F238E27FC236}">
-                <a16:creationId xmlns:a16="http://schemas.microsoft.com/office/drawing/2014/main" id="{49FF5432-20AB-422A-ADD8-2FF7C34E0CF0}"/>
+                <a16:creationId xmlns:a16="http://schemas.microsoft.com/office/drawing/2014/main" id="{A6D8F066-90FF-4E37-8971-1357EE85CA22}"/>
               </a:ext>
             </a:extLst>
           </p:cNvPr>
@@ -3239,7 +3239,7 @@
           <p:cNvPr id="9" name="bullet-2">
             <a:extLst xmlns:a="http://schemas.openxmlformats.org/drawingml/2006/main">
               <a:ext uri="{FF2B5EF4-FFF2-40B4-BE49-F238E27FC236}">
-                <a16:creationId xmlns:a16="http://schemas.microsoft.com/office/drawing/2014/main" id="{B14785B3-127B-4CA6-9385-ACCCFDB87438}"/>
+                <a16:creationId xmlns:a16="http://schemas.microsoft.com/office/drawing/2014/main" id="{510B0D19-4B96-4E0D-BE54-00016BB4437D}"/>
               </a:ext>
             </a:extLst>
           </p:cNvPr>
@@ -3301,7 +3301,7 @@
           <p:cNvPr id="10" name="bullet-mark-3">
             <a:extLst xmlns:a="http://schemas.openxmlformats.org/drawingml/2006/main">
               <a:ext uri="{FF2B5EF4-FFF2-40B4-BE49-F238E27FC236}">
-                <a16:creationId xmlns:a16="http://schemas.microsoft.com/office/drawing/2014/main" id="{1FC020AA-0B8A-413D-A983-112537EF3E78}"/>
+                <a16:creationId xmlns:a16="http://schemas.microsoft.com/office/drawing/2014/main" id="{F0B9C1A8-DBB2-4CF7-B9F9-BC0E7697A337}"/>
               </a:ext>
             </a:extLst>
           </p:cNvPr>
@@ -3363,7 +3363,7 @@
           <p:cNvPr id="11" name="bullet-3">
             <a:extLst xmlns:a="http://schemas.openxmlformats.org/drawingml/2006/main">
               <a:ext uri="{FF2B5EF4-FFF2-40B4-BE49-F238E27FC236}">
-                <a16:creationId xmlns:a16="http://schemas.microsoft.com/office/drawing/2014/main" id="{4F49A6B8-E9DF-4226-BA10-945FF47CC6FE}"/>
+                <a16:creationId xmlns:a16="http://schemas.microsoft.com/office/drawing/2014/main" id="{B6028266-6038-48C7-9B47-ACF9BDB7C08F}"/>
               </a:ext>
             </a:extLst>
           </p:cNvPr>
@@ -3425,7 +3425,7 @@
           <p:cNvPr id="12" name="bullet-mark-4">
             <a:extLst xmlns:a="http://schemas.openxmlformats.org/drawingml/2006/main">
               <a:ext uri="{FF2B5EF4-FFF2-40B4-BE49-F238E27FC236}">
-                <a16:creationId xmlns:a16="http://schemas.microsoft.com/office/drawing/2014/main" id="{DEB4C2AA-3DE1-43FA-8D5F-DA01A2625DD2}"/>
+                <a16:creationId xmlns:a16="http://schemas.microsoft.com/office/drawing/2014/main" id="{3251CB48-C80B-47B1-AE6C-EFB586D265BB}"/>
               </a:ext>
             </a:extLst>
           </p:cNvPr>
@@ -3487,7 +3487,7 @@
           <p:cNvPr id="13" name="bullet-4">
             <a:extLst xmlns:a="http://schemas.openxmlformats.org/drawingml/2006/main">
               <a:ext uri="{FF2B5EF4-FFF2-40B4-BE49-F238E27FC236}">
-                <a16:creationId xmlns:a16="http://schemas.microsoft.com/office/drawing/2014/main" id="{9981CD1D-A821-4A89-A277-C4C92A44E590}"/>
+                <a16:creationId xmlns:a16="http://schemas.microsoft.com/office/drawing/2014/main" id="{952BFC35-B06D-4834-AC49-DA740048FB30}"/>
               </a:ext>
             </a:extLst>
           </p:cNvPr>
@@ -3549,7 +3549,7 @@
           <p:cNvPr id="14" name="bullet-mark-5">
             <a:extLst xmlns:a="http://schemas.openxmlformats.org/drawingml/2006/main">
               <a:ext uri="{FF2B5EF4-FFF2-40B4-BE49-F238E27FC236}">
-                <a16:creationId xmlns:a16="http://schemas.microsoft.com/office/drawing/2014/main" id="{D260148D-D2C2-4E70-9DF6-DE4015DCC45E}"/>
+                <a16:creationId xmlns:a16="http://schemas.microsoft.com/office/drawing/2014/main" id="{ECD10E68-2516-4339-BEB6-25A6BCA0CAB4}"/>
               </a:ext>
             </a:extLst>
           </p:cNvPr>
@@ -3611,7 +3611,7 @@
           <p:cNvPr id="15" name="bullet-5">
             <a:extLst xmlns:a="http://schemas.openxmlformats.org/drawingml/2006/main">
               <a:ext uri="{FF2B5EF4-FFF2-40B4-BE49-F238E27FC236}">
-                <a16:creationId xmlns:a16="http://schemas.microsoft.com/office/drawing/2014/main" id="{2CD701FD-0207-44C9-8ECB-BECE6CCBB659}"/>
+                <a16:creationId xmlns:a16="http://schemas.microsoft.com/office/drawing/2014/main" id="{6C919C1E-4391-4F9A-9581-51A0A4608502}"/>
               </a:ext>
             </a:extLst>
           </p:cNvPr>
@@ -3673,7 +3673,7 @@
           <p:cNvPr id="16" name="">
             <a:extLst xmlns:a="http://schemas.openxmlformats.org/drawingml/2006/main">
               <a:ext uri="{FF2B5EF4-FFF2-40B4-BE49-F238E27FC236}">
-                <a16:creationId xmlns:a16="http://schemas.microsoft.com/office/drawing/2014/main" id="{D94F19BF-A6C0-4A2B-B9EF-B99C072A259B}"/>
+                <a16:creationId xmlns:a16="http://schemas.microsoft.com/office/drawing/2014/main" id="{AC5C468C-551F-4BF6-9372-BC225FD675CD}"/>
               </a:ext>
             </a:extLst>
           </p:cNvPr>
@@ -3733,7 +3733,7 @@
     </p:spTree>
     <p:extLst>
       <p:ext uri="{BB962C8B-B14F-4D97-AF65-F5344CB8AC3E}">
-        <p14:creationId xmlns:p14="http://schemas.microsoft.com/office/powerpoint/2010/main" val="318114638"/>
+        <p14:creationId xmlns:p14="http://schemas.microsoft.com/office/powerpoint/2010/main" val="1959293630"/>
       </p:ext>
     </p:extLst>
   </p:cSld>
@@ -3764,7 +3764,7 @@
           <p:cNvPr id="18" name="chapter-label">
             <a:extLst xmlns:a="http://schemas.openxmlformats.org/drawingml/2006/main">
               <a:ext uri="{FF2B5EF4-FFF2-40B4-BE49-F238E27FC236}">
-                <a16:creationId xmlns:a16="http://schemas.microsoft.com/office/drawing/2014/main" id="{0DD7E426-8F54-483D-8BC5-9FD655ED8A14}"/>
+                <a16:creationId xmlns:a16="http://schemas.microsoft.com/office/drawing/2014/main" id="{4FC6AB67-DF6C-47AE-9895-BFBC6E1F1D97}"/>
               </a:ext>
             </a:extLst>
           </p:cNvPr>
@@ -3826,7 +3826,7 @@
           <p:cNvPr id="2" name="slide-title">
             <a:extLst xmlns:a="http://schemas.openxmlformats.org/drawingml/2006/main">
               <a:ext uri="{FF2B5EF4-FFF2-40B4-BE49-F238E27FC236}">
-                <a16:creationId xmlns:a16="http://schemas.microsoft.com/office/drawing/2014/main" id="{E7D180A6-4424-4883-AA72-451D0E4AD054}"/>
+                <a16:creationId xmlns:a16="http://schemas.microsoft.com/office/drawing/2014/main" id="{D028FE8D-0803-48F0-AA99-E6E7CB96C17C}"/>
               </a:ext>
             </a:extLst>
           </p:cNvPr>
@@ -3888,7 +3888,7 @@
           <p:cNvPr id="3" name="footer-rule">
             <a:extLst xmlns:a="http://schemas.openxmlformats.org/drawingml/2006/main">
               <a:ext uri="{FF2B5EF4-FFF2-40B4-BE49-F238E27FC236}">
-                <a16:creationId xmlns:a16="http://schemas.microsoft.com/office/drawing/2014/main" id="{EAC512C0-6B36-451E-98CD-FF0119811D8D}"/>
+                <a16:creationId xmlns:a16="http://schemas.microsoft.com/office/drawing/2014/main" id="{8A8559CE-9C0F-4927-B69E-AF14E36387E8}"/>
               </a:ext>
             </a:extLst>
           </p:cNvPr>
@@ -3919,7 +3919,7 @@
           <p:cNvPr id="4" name="footer-book">
             <a:extLst xmlns:a="http://schemas.openxmlformats.org/drawingml/2006/main">
               <a:ext uri="{FF2B5EF4-FFF2-40B4-BE49-F238E27FC236}">
-                <a16:creationId xmlns:a16="http://schemas.microsoft.com/office/drawing/2014/main" id="{CC10B062-DDCD-4B0E-9CD8-4DE57A52B912}"/>
+                <a16:creationId xmlns:a16="http://schemas.microsoft.com/office/drawing/2014/main" id="{7FC36F57-458E-4A6C-9F80-65BC688D9EF1}"/>
               </a:ext>
             </a:extLst>
           </p:cNvPr>
@@ -3981,7 +3981,7 @@
           <p:cNvPr id="5" name="footer-number">
             <a:extLst xmlns:a="http://schemas.openxmlformats.org/drawingml/2006/main">
               <a:ext uri="{FF2B5EF4-FFF2-40B4-BE49-F238E27FC236}">
-                <a16:creationId xmlns:a16="http://schemas.microsoft.com/office/drawing/2014/main" id="{6E75524D-27A7-4086-9B63-463FFA7352F6}"/>
+                <a16:creationId xmlns:a16="http://schemas.microsoft.com/office/drawing/2014/main" id="{4CAF1FE1-7612-49D0-A421-F458E8013060}"/>
               </a:ext>
             </a:extLst>
           </p:cNvPr>
@@ -4043,7 +4043,7 @@
           <p:cNvPr id="6" name="">
             <a:extLst xmlns:a="http://schemas.openxmlformats.org/drawingml/2006/main">
               <a:ext uri="{FF2B5EF4-FFF2-40B4-BE49-F238E27FC236}">
-                <a16:creationId xmlns:a16="http://schemas.microsoft.com/office/drawing/2014/main" id="{AFDE4043-BDED-48F6-B20E-038BBAD92146}"/>
+                <a16:creationId xmlns:a16="http://schemas.microsoft.com/office/drawing/2014/main" id="{7DA34308-09BB-4E23-A455-745F2A814489}"/>
               </a:ext>
             </a:extLst>
           </p:cNvPr>
@@ -4105,7 +4105,7 @@
           <p:cNvPr id="7" name="bullet-mark-1">
             <a:extLst xmlns:a="http://schemas.openxmlformats.org/drawingml/2006/main">
               <a:ext uri="{FF2B5EF4-FFF2-40B4-BE49-F238E27FC236}">
-                <a16:creationId xmlns:a16="http://schemas.microsoft.com/office/drawing/2014/main" id="{6C8D743E-AADD-4787-A5E8-E2BAA7EA7933}"/>
+                <a16:creationId xmlns:a16="http://schemas.microsoft.com/office/drawing/2014/main" id="{4B1D4AED-D9D4-4B72-B1D1-A26E4DEA45F6}"/>
               </a:ext>
             </a:extLst>
           </p:cNvPr>
@@ -4167,7 +4167,7 @@
           <p:cNvPr id="8" name="bullet-1">
             <a:extLst xmlns:a="http://schemas.openxmlformats.org/drawingml/2006/main">
               <a:ext uri="{FF2B5EF4-FFF2-40B4-BE49-F238E27FC236}">
-                <a16:creationId xmlns:a16="http://schemas.microsoft.com/office/drawing/2014/main" id="{1C8B9504-7E9B-4C4E-B904-00AD6F70D94D}"/>
+                <a16:creationId xmlns:a16="http://schemas.microsoft.com/office/drawing/2014/main" id="{B60CE2CD-5285-462D-B2EC-D34BEBF13084}"/>
               </a:ext>
             </a:extLst>
           </p:cNvPr>
@@ -4229,7 +4229,7 @@
           <p:cNvPr id="9" name="bullet-mark-2">
             <a:extLst xmlns:a="http://schemas.openxmlformats.org/drawingml/2006/main">
               <a:ext uri="{FF2B5EF4-FFF2-40B4-BE49-F238E27FC236}">
-                <a16:creationId xmlns:a16="http://schemas.microsoft.com/office/drawing/2014/main" id="{671ECB11-D4E1-444A-9DCB-1D674A613AB5}"/>
+                <a16:creationId xmlns:a16="http://schemas.microsoft.com/office/drawing/2014/main" id="{8D9FC5D0-CA72-4DA9-BDA1-268A0880C674}"/>
               </a:ext>
             </a:extLst>
           </p:cNvPr>
@@ -4291,7 +4291,7 @@
           <p:cNvPr id="10" name="bullet-2">
             <a:extLst xmlns:a="http://schemas.openxmlformats.org/drawingml/2006/main">
               <a:ext uri="{FF2B5EF4-FFF2-40B4-BE49-F238E27FC236}">
-                <a16:creationId xmlns:a16="http://schemas.microsoft.com/office/drawing/2014/main" id="{5795AC2B-3A32-44F7-B637-AF3EAAFBAF15}"/>
+                <a16:creationId xmlns:a16="http://schemas.microsoft.com/office/drawing/2014/main" id="{BE803655-20F9-4BE8-82D3-DFEFC3D92A28}"/>
               </a:ext>
             </a:extLst>
           </p:cNvPr>
@@ -4353,7 +4353,7 @@
           <p:cNvPr id="11" name="bullet-mark-3">
             <a:extLst xmlns:a="http://schemas.openxmlformats.org/drawingml/2006/main">
               <a:ext uri="{FF2B5EF4-FFF2-40B4-BE49-F238E27FC236}">
-                <a16:creationId xmlns:a16="http://schemas.microsoft.com/office/drawing/2014/main" id="{74FF69BE-6733-4A48-85D3-645A8461D341}"/>
+                <a16:creationId xmlns:a16="http://schemas.microsoft.com/office/drawing/2014/main" id="{5DD867CF-E4AC-4C76-B19D-7B550A58990B}"/>
               </a:ext>
             </a:extLst>
           </p:cNvPr>
@@ -4415,7 +4415,7 @@
           <p:cNvPr id="12" name="bullet-3">
             <a:extLst xmlns:a="http://schemas.openxmlformats.org/drawingml/2006/main">
               <a:ext uri="{FF2B5EF4-FFF2-40B4-BE49-F238E27FC236}">
-                <a16:creationId xmlns:a16="http://schemas.microsoft.com/office/drawing/2014/main" id="{485DBC0A-E984-4BE8-AC29-9C4033AB9FA8}"/>
+                <a16:creationId xmlns:a16="http://schemas.microsoft.com/office/drawing/2014/main" id="{380095BA-0B0F-42D6-9F68-CA567B92BD86}"/>
               </a:ext>
             </a:extLst>
           </p:cNvPr>
@@ -4477,7 +4477,7 @@
           <p:cNvPr id="13" name="bullet-mark-4">
             <a:extLst xmlns:a="http://schemas.openxmlformats.org/drawingml/2006/main">
               <a:ext uri="{FF2B5EF4-FFF2-40B4-BE49-F238E27FC236}">
-                <a16:creationId xmlns:a16="http://schemas.microsoft.com/office/drawing/2014/main" id="{03FF5F21-C00A-4C19-97D1-993351B679D4}"/>
+                <a16:creationId xmlns:a16="http://schemas.microsoft.com/office/drawing/2014/main" id="{2CAF8AFC-AF9D-4D60-838B-ACCCCC210F6A}"/>
               </a:ext>
             </a:extLst>
           </p:cNvPr>
@@ -4539,7 +4539,7 @@
           <p:cNvPr id="14" name="bullet-4">
             <a:extLst xmlns:a="http://schemas.openxmlformats.org/drawingml/2006/main">
               <a:ext uri="{FF2B5EF4-FFF2-40B4-BE49-F238E27FC236}">
-                <a16:creationId xmlns:a16="http://schemas.microsoft.com/office/drawing/2014/main" id="{6288B9C1-8339-4339-A842-6882A3923BA7}"/>
+                <a16:creationId xmlns:a16="http://schemas.microsoft.com/office/drawing/2014/main" id="{BBF54136-7294-483D-AA93-823C312B7365}"/>
               </a:ext>
             </a:extLst>
           </p:cNvPr>
@@ -4601,7 +4601,7 @@
           <p:cNvPr id="15" name="bullet-mark-5">
             <a:extLst xmlns:a="http://schemas.openxmlformats.org/drawingml/2006/main">
               <a:ext uri="{FF2B5EF4-FFF2-40B4-BE49-F238E27FC236}">
-                <a16:creationId xmlns:a16="http://schemas.microsoft.com/office/drawing/2014/main" id="{7274FB64-5624-491A-BEBB-C8C1F6279517}"/>
+                <a16:creationId xmlns:a16="http://schemas.microsoft.com/office/drawing/2014/main" id="{FBF73E17-33FD-4CEA-AC0D-4491D3F86EBB}"/>
               </a:ext>
             </a:extLst>
           </p:cNvPr>
@@ -4663,7 +4663,7 @@
           <p:cNvPr id="16" name="bullet-5">
             <a:extLst xmlns:a="http://schemas.openxmlformats.org/drawingml/2006/main">
               <a:ext uri="{FF2B5EF4-FFF2-40B4-BE49-F238E27FC236}">
-                <a16:creationId xmlns:a16="http://schemas.microsoft.com/office/drawing/2014/main" id="{A9A5F8A7-A7DD-404F-A995-CB94F0BBE66E}"/>
+                <a16:creationId xmlns:a16="http://schemas.microsoft.com/office/drawing/2014/main" id="{48998126-A555-4615-A0FF-3B06806D4F0D}"/>
               </a:ext>
             </a:extLst>
           </p:cNvPr>
@@ -4725,7 +4725,7 @@
           <p:cNvPr id="17" name="">
             <a:extLst xmlns:a="http://schemas.openxmlformats.org/drawingml/2006/main">
               <a:ext uri="{FF2B5EF4-FFF2-40B4-BE49-F238E27FC236}">
-                <a16:creationId xmlns:a16="http://schemas.microsoft.com/office/drawing/2014/main" id="{602E2A1F-F1C0-4382-871B-F5FA3975AE8D}"/>
+                <a16:creationId xmlns:a16="http://schemas.microsoft.com/office/drawing/2014/main" id="{91961DE4-C99A-48BE-8BFF-8FBBA018C24F}"/>
               </a:ext>
             </a:extLst>
           </p:cNvPr>
@@ -4785,7 +4785,7 @@
     </p:spTree>
     <p:extLst>
       <p:ext uri="{BB962C8B-B14F-4D97-AF65-F5344CB8AC3E}">
-        <p14:creationId xmlns:p14="http://schemas.microsoft.com/office/powerpoint/2010/main" val="236484156"/>
+        <p14:creationId xmlns:p14="http://schemas.microsoft.com/office/powerpoint/2010/main" val="149497250"/>
       </p:ext>
     </p:extLst>
   </p:cSld>
@@ -4816,7 +4816,7 @@
           <p:cNvPr id="8" name="chapter-label">
             <a:extLst xmlns:a="http://schemas.openxmlformats.org/drawingml/2006/main">
               <a:ext uri="{FF2B5EF4-FFF2-40B4-BE49-F238E27FC236}">
-                <a16:creationId xmlns:a16="http://schemas.microsoft.com/office/drawing/2014/main" id="{3ABD1B47-6A67-4958-A60B-D0901A199261}"/>
+                <a16:creationId xmlns:a16="http://schemas.microsoft.com/office/drawing/2014/main" id="{BA54C7C2-3F81-49B0-8120-018AB2FD5C8A}"/>
               </a:ext>
             </a:extLst>
           </p:cNvPr>
@@ -4878,7 +4878,7 @@
           <p:cNvPr id="2" name="slide-title">
             <a:extLst xmlns:a="http://schemas.openxmlformats.org/drawingml/2006/main">
               <a:ext uri="{FF2B5EF4-FFF2-40B4-BE49-F238E27FC236}">
-                <a16:creationId xmlns:a16="http://schemas.microsoft.com/office/drawing/2014/main" id="{32334604-0522-48C3-A582-E5DF6BD46A9E}"/>
+                <a16:creationId xmlns:a16="http://schemas.microsoft.com/office/drawing/2014/main" id="{8A23FB94-5A3C-4942-8390-23374DC23DEE}"/>
               </a:ext>
             </a:extLst>
           </p:cNvPr>
@@ -4940,7 +4940,7 @@
           <p:cNvPr id="3" name="footer-rule">
             <a:extLst xmlns:a="http://schemas.openxmlformats.org/drawingml/2006/main">
               <a:ext uri="{FF2B5EF4-FFF2-40B4-BE49-F238E27FC236}">
-                <a16:creationId xmlns:a16="http://schemas.microsoft.com/office/drawing/2014/main" id="{59DE50A9-BB89-4286-92E9-A52B674C81C4}"/>
+                <a16:creationId xmlns:a16="http://schemas.microsoft.com/office/drawing/2014/main" id="{749BF074-4062-4C6B-B5D3-9E623E53CAD2}"/>
               </a:ext>
             </a:extLst>
           </p:cNvPr>
@@ -4971,7 +4971,7 @@
           <p:cNvPr id="4" name="footer-book">
             <a:extLst xmlns:a="http://schemas.openxmlformats.org/drawingml/2006/main">
               <a:ext uri="{FF2B5EF4-FFF2-40B4-BE49-F238E27FC236}">
-                <a16:creationId xmlns:a16="http://schemas.microsoft.com/office/drawing/2014/main" id="{020E4F8D-7A34-4FE0-8DBA-597E3F68F812}"/>
+                <a16:creationId xmlns:a16="http://schemas.microsoft.com/office/drawing/2014/main" id="{4ED4526C-085E-491C-B219-7A5DC78D17F3}"/>
               </a:ext>
             </a:extLst>
           </p:cNvPr>
@@ -5033,7 +5033,7 @@
           <p:cNvPr id="5" name="footer-number">
             <a:extLst xmlns:a="http://schemas.openxmlformats.org/drawingml/2006/main">
               <a:ext uri="{FF2B5EF4-FFF2-40B4-BE49-F238E27FC236}">
-                <a16:creationId xmlns:a16="http://schemas.microsoft.com/office/drawing/2014/main" id="{A6FEB9CB-7B4B-4C82-90F9-A6F7D894561B}"/>
+                <a16:creationId xmlns:a16="http://schemas.microsoft.com/office/drawing/2014/main" id="{4647317E-BD6B-4CB0-8FF8-683E4C2E8AE8}"/>
               </a:ext>
             </a:extLst>
           </p:cNvPr>
@@ -5099,7 +5099,7 @@
           <p:nvPr/>
         </p:nvPicPr>
         <p:blipFill>
-          <a:blip xmlns:r="http://schemas.openxmlformats.org/officeDocument/2006/relationships" xmlns:a="http://schemas.openxmlformats.org/drawingml/2006/main" r:embed="Rea90982132e84daf"/>
+          <a:blip xmlns:r="http://schemas.openxmlformats.org/officeDocument/2006/relationships" xmlns:a="http://schemas.openxmlformats.org/drawingml/2006/main" r:embed="R28121265353a4734"/>
           <a:stretch xmlns:a="http://schemas.openxmlformats.org/drawingml/2006/main"/>
         </p:blipFill>
         <p:spPr>
@@ -5117,7 +5117,7 @@
           <p:cNvPr id="7" name="">
             <a:extLst xmlns:a="http://schemas.openxmlformats.org/drawingml/2006/main">
               <a:ext uri="{FF2B5EF4-FFF2-40B4-BE49-F238E27FC236}">
-                <a16:creationId xmlns:a16="http://schemas.microsoft.com/office/drawing/2014/main" id="{01B066C0-CEFE-4C3E-9A3D-2C93C46B7797}"/>
+                <a16:creationId xmlns:a16="http://schemas.microsoft.com/office/drawing/2014/main" id="{10ACFE69-47B8-4C88-A7A8-DF4145FFA287}"/>
               </a:ext>
             </a:extLst>
           </p:cNvPr>
@@ -5177,7 +5177,7 @@
     </p:spTree>
     <p:extLst>
       <p:ext uri="{BB962C8B-B14F-4D97-AF65-F5344CB8AC3E}">
-        <p14:creationId xmlns:p14="http://schemas.microsoft.com/office/powerpoint/2010/main" val="878775632"/>
+        <p14:creationId xmlns:p14="http://schemas.microsoft.com/office/powerpoint/2010/main" val="187661038"/>
       </p:ext>
     </p:extLst>
   </p:cSld>
@@ -5208,7 +5208,7 @@
           <p:cNvPr id="15" name="chapter-label">
             <a:extLst xmlns:a="http://schemas.openxmlformats.org/drawingml/2006/main">
               <a:ext uri="{FF2B5EF4-FFF2-40B4-BE49-F238E27FC236}">
-                <a16:creationId xmlns:a16="http://schemas.microsoft.com/office/drawing/2014/main" id="{5A29F0BA-FBA8-402C-9415-841760FD9DE5}"/>
+                <a16:creationId xmlns:a16="http://schemas.microsoft.com/office/drawing/2014/main" id="{FCC1368A-57F8-4CC8-9B8C-88DC4363F558}"/>
               </a:ext>
             </a:extLst>
           </p:cNvPr>
@@ -5270,7 +5270,7 @@
           <p:cNvPr id="2" name="slide-title">
             <a:extLst xmlns:a="http://schemas.openxmlformats.org/drawingml/2006/main">
               <a:ext uri="{FF2B5EF4-FFF2-40B4-BE49-F238E27FC236}">
-                <a16:creationId xmlns:a16="http://schemas.microsoft.com/office/drawing/2014/main" id="{19EEEDFB-BFF7-4F76-8406-DDD38B825C7C}"/>
+                <a16:creationId xmlns:a16="http://schemas.microsoft.com/office/drawing/2014/main" id="{87BE6EDF-A376-4837-B950-421CB2A20581}"/>
               </a:ext>
             </a:extLst>
           </p:cNvPr>
@@ -5332,7 +5332,7 @@
           <p:cNvPr id="3" name="footer-rule">
             <a:extLst xmlns:a="http://schemas.openxmlformats.org/drawingml/2006/main">
               <a:ext uri="{FF2B5EF4-FFF2-40B4-BE49-F238E27FC236}">
-                <a16:creationId xmlns:a16="http://schemas.microsoft.com/office/drawing/2014/main" id="{1DDCCF8D-9957-4036-9477-A337DFF42FBC}"/>
+                <a16:creationId xmlns:a16="http://schemas.microsoft.com/office/drawing/2014/main" id="{9A4290E6-B41F-45FA-85B5-8B6BAE4DF755}"/>
               </a:ext>
             </a:extLst>
           </p:cNvPr>
@@ -5363,7 +5363,7 @@
           <p:cNvPr id="4" name="footer-book">
             <a:extLst xmlns:a="http://schemas.openxmlformats.org/drawingml/2006/main">
               <a:ext uri="{FF2B5EF4-FFF2-40B4-BE49-F238E27FC236}">
-                <a16:creationId xmlns:a16="http://schemas.microsoft.com/office/drawing/2014/main" id="{FAB1B705-15E8-4B60-AD62-ECD787B2BA9A}"/>
+                <a16:creationId xmlns:a16="http://schemas.microsoft.com/office/drawing/2014/main" id="{BEC1E7C3-2BBF-47F6-838E-7A485009334C}"/>
               </a:ext>
             </a:extLst>
           </p:cNvPr>
@@ -5425,7 +5425,7 @@
           <p:cNvPr id="5" name="footer-number">
             <a:extLst xmlns:a="http://schemas.openxmlformats.org/drawingml/2006/main">
               <a:ext uri="{FF2B5EF4-FFF2-40B4-BE49-F238E27FC236}">
-                <a16:creationId xmlns:a16="http://schemas.microsoft.com/office/drawing/2014/main" id="{B9E85B5F-D8D3-4CE2-A61B-4A562F5CE2D4}"/>
+                <a16:creationId xmlns:a16="http://schemas.microsoft.com/office/drawing/2014/main" id="{28E75727-54AC-48F7-9A0A-7E48219B9CCE}"/>
               </a:ext>
             </a:extLst>
           </p:cNvPr>
@@ -5487,7 +5487,7 @@
           <p:cNvPr id="6" name="panel-1">
             <a:extLst xmlns:a="http://schemas.openxmlformats.org/drawingml/2006/main">
               <a:ext uri="{FF2B5EF4-FFF2-40B4-BE49-F238E27FC236}">
-                <a16:creationId xmlns:a16="http://schemas.microsoft.com/office/drawing/2014/main" id="{322D3E8A-6CBD-42D6-AEAF-4220B80AC106}"/>
+                <a16:creationId xmlns:a16="http://schemas.microsoft.com/office/drawing/2014/main" id="{9232EF94-3B50-4F0E-A051-E9CB58FE3098}"/>
               </a:ext>
             </a:extLst>
           </p:cNvPr>
@@ -5520,7 +5520,7 @@
           <p:cNvPr id="7" name="">
             <a:extLst xmlns:a="http://schemas.openxmlformats.org/drawingml/2006/main">
               <a:ext uri="{FF2B5EF4-FFF2-40B4-BE49-F238E27FC236}">
-                <a16:creationId xmlns:a16="http://schemas.microsoft.com/office/drawing/2014/main" id="{88003355-B0F9-4AE4-83D9-39C3D54D8F10}"/>
+                <a16:creationId xmlns:a16="http://schemas.microsoft.com/office/drawing/2014/main" id="{28B30F40-BD28-4DDA-ABD3-D0AB4C26833F}"/>
               </a:ext>
             </a:extLst>
           </p:cNvPr>
@@ -5582,7 +5582,7 @@
           <p:cNvPr id="8" name="">
             <a:extLst xmlns:a="http://schemas.openxmlformats.org/drawingml/2006/main">
               <a:ext uri="{FF2B5EF4-FFF2-40B4-BE49-F238E27FC236}">
-                <a16:creationId xmlns:a16="http://schemas.microsoft.com/office/drawing/2014/main" id="{25BD05D1-4D8B-4BD6-8579-A2530C5ED758}"/>
+                <a16:creationId xmlns:a16="http://schemas.microsoft.com/office/drawing/2014/main" id="{9457F7B9-2DA8-449A-BAB9-2AB2C1EC8F0A}"/>
               </a:ext>
             </a:extLst>
           </p:cNvPr>
@@ -5644,7 +5644,7 @@
           <p:cNvPr id="9" name="">
             <a:extLst xmlns:a="http://schemas.openxmlformats.org/drawingml/2006/main">
               <a:ext uri="{FF2B5EF4-FFF2-40B4-BE49-F238E27FC236}">
-                <a16:creationId xmlns:a16="http://schemas.microsoft.com/office/drawing/2014/main" id="{1540FB2E-8118-4164-8FE9-363408B453A4}"/>
+                <a16:creationId xmlns:a16="http://schemas.microsoft.com/office/drawing/2014/main" id="{C9D4BE4F-1255-4AAA-90ED-326C410B0FB2}"/>
               </a:ext>
             </a:extLst>
           </p:cNvPr>
@@ -5706,7 +5706,7 @@
           <p:cNvPr id="10" name="panel-2">
             <a:extLst xmlns:a="http://schemas.openxmlformats.org/drawingml/2006/main">
               <a:ext uri="{FF2B5EF4-FFF2-40B4-BE49-F238E27FC236}">
-                <a16:creationId xmlns:a16="http://schemas.microsoft.com/office/drawing/2014/main" id="{DEBC4DDD-5805-49A2-AC59-D78424E4CE65}"/>
+                <a16:creationId xmlns:a16="http://schemas.microsoft.com/office/drawing/2014/main" id="{05E5B7B5-B912-4B8F-BA58-64CC5C0B3BB0}"/>
               </a:ext>
             </a:extLst>
           </p:cNvPr>
@@ -5739,7 +5739,7 @@
           <p:cNvPr id="11" name="">
             <a:extLst xmlns:a="http://schemas.openxmlformats.org/drawingml/2006/main">
               <a:ext uri="{FF2B5EF4-FFF2-40B4-BE49-F238E27FC236}">
-                <a16:creationId xmlns:a16="http://schemas.microsoft.com/office/drawing/2014/main" id="{0383B779-D32F-4582-BB21-BF9BB481D7C2}"/>
+                <a16:creationId xmlns:a16="http://schemas.microsoft.com/office/drawing/2014/main" id="{CE46FA79-B21A-4A42-94CE-E1A62AE9CB5A}"/>
               </a:ext>
             </a:extLst>
           </p:cNvPr>
@@ -5801,7 +5801,7 @@
           <p:cNvPr id="12" name="">
             <a:extLst xmlns:a="http://schemas.openxmlformats.org/drawingml/2006/main">
               <a:ext uri="{FF2B5EF4-FFF2-40B4-BE49-F238E27FC236}">
-                <a16:creationId xmlns:a16="http://schemas.microsoft.com/office/drawing/2014/main" id="{4F542F7F-8299-445D-B06F-C544A7DAFA0E}"/>
+                <a16:creationId xmlns:a16="http://schemas.microsoft.com/office/drawing/2014/main" id="{578B4059-2E05-48D6-958F-A93079BAFC99}"/>
               </a:ext>
             </a:extLst>
           </p:cNvPr>
@@ -5863,7 +5863,7 @@
           <p:cNvPr id="13" name="">
             <a:extLst xmlns:a="http://schemas.openxmlformats.org/drawingml/2006/main">
               <a:ext uri="{FF2B5EF4-FFF2-40B4-BE49-F238E27FC236}">
-                <a16:creationId xmlns:a16="http://schemas.microsoft.com/office/drawing/2014/main" id="{D9A07DA4-F2DE-43DE-BEA9-2704108B9EA8}"/>
+                <a16:creationId xmlns:a16="http://schemas.microsoft.com/office/drawing/2014/main" id="{593110EE-EB19-4F3C-B7A3-5A4D4C01EEA3}"/>
               </a:ext>
             </a:extLst>
           </p:cNvPr>
@@ -5925,7 +5925,7 @@
           <p:cNvPr id="14" name="">
             <a:extLst xmlns:a="http://schemas.openxmlformats.org/drawingml/2006/main">
               <a:ext uri="{FF2B5EF4-FFF2-40B4-BE49-F238E27FC236}">
-                <a16:creationId xmlns:a16="http://schemas.microsoft.com/office/drawing/2014/main" id="{3B634C17-43B4-4FAC-9D1A-670EBED64BA4}"/>
+                <a16:creationId xmlns:a16="http://schemas.microsoft.com/office/drawing/2014/main" id="{04682E99-ECF6-47A7-AA51-C358CEB37FB3}"/>
               </a:ext>
             </a:extLst>
           </p:cNvPr>
@@ -5985,7 +5985,7 @@
     </p:spTree>
     <p:extLst>
       <p:ext uri="{BB962C8B-B14F-4D97-AF65-F5344CB8AC3E}">
-        <p14:creationId xmlns:p14="http://schemas.microsoft.com/office/powerpoint/2010/main" val="1339814122"/>
+        <p14:creationId xmlns:p14="http://schemas.microsoft.com/office/powerpoint/2010/main" val="231025691"/>
       </p:ext>
     </p:extLst>
   </p:cSld>
@@ -6016,7 +6016,7 @@
           <p:cNvPr id="8" name="chapter-label">
             <a:extLst xmlns:a="http://schemas.openxmlformats.org/drawingml/2006/main">
               <a:ext uri="{FF2B5EF4-FFF2-40B4-BE49-F238E27FC236}">
-                <a16:creationId xmlns:a16="http://schemas.microsoft.com/office/drawing/2014/main" id="{2C5B3DCD-9AA3-45B8-A7A9-51ACA89A6BA6}"/>
+                <a16:creationId xmlns:a16="http://schemas.microsoft.com/office/drawing/2014/main" id="{CFEEE981-8114-48BB-9521-AB92BCD93DAF}"/>
               </a:ext>
             </a:extLst>
           </p:cNvPr>
@@ -6078,7 +6078,7 @@
           <p:cNvPr id="2" name="slide-title">
             <a:extLst xmlns:a="http://schemas.openxmlformats.org/drawingml/2006/main">
               <a:ext uri="{FF2B5EF4-FFF2-40B4-BE49-F238E27FC236}">
-                <a16:creationId xmlns:a16="http://schemas.microsoft.com/office/drawing/2014/main" id="{819F7330-945E-42A6-BA89-DD835F3A5F3B}"/>
+                <a16:creationId xmlns:a16="http://schemas.microsoft.com/office/drawing/2014/main" id="{5E3EA0DB-EE0E-4222-A492-94771DAF4BBE}"/>
               </a:ext>
             </a:extLst>
           </p:cNvPr>
@@ -6140,7 +6140,7 @@
           <p:cNvPr id="3" name="footer-rule">
             <a:extLst xmlns:a="http://schemas.openxmlformats.org/drawingml/2006/main">
               <a:ext uri="{FF2B5EF4-FFF2-40B4-BE49-F238E27FC236}">
-                <a16:creationId xmlns:a16="http://schemas.microsoft.com/office/drawing/2014/main" id="{65F3B884-2B2F-4699-88FF-7D0306BD5C6B}"/>
+                <a16:creationId xmlns:a16="http://schemas.microsoft.com/office/drawing/2014/main" id="{A5BB3517-89CC-411E-8C60-38F1F238C4EC}"/>
               </a:ext>
             </a:extLst>
           </p:cNvPr>
@@ -6171,7 +6171,7 @@
           <p:cNvPr id="4" name="footer-book">
             <a:extLst xmlns:a="http://schemas.openxmlformats.org/drawingml/2006/main">
               <a:ext uri="{FF2B5EF4-FFF2-40B4-BE49-F238E27FC236}">
-                <a16:creationId xmlns:a16="http://schemas.microsoft.com/office/drawing/2014/main" id="{F40E8663-C8B4-460B-8508-C67D2FD04EA6}"/>
+                <a16:creationId xmlns:a16="http://schemas.microsoft.com/office/drawing/2014/main" id="{AAB4348C-2A54-4C70-A8AA-A74B73BA5EBA}"/>
               </a:ext>
             </a:extLst>
           </p:cNvPr>
@@ -6233,7 +6233,7 @@
           <p:cNvPr id="5" name="footer-number">
             <a:extLst xmlns:a="http://schemas.openxmlformats.org/drawingml/2006/main">
               <a:ext uri="{FF2B5EF4-FFF2-40B4-BE49-F238E27FC236}">
-                <a16:creationId xmlns:a16="http://schemas.microsoft.com/office/drawing/2014/main" id="{D05193EF-2940-4F0C-B210-FC7A0A2E33F2}"/>
+                <a16:creationId xmlns:a16="http://schemas.microsoft.com/office/drawing/2014/main" id="{EDAF394D-8D30-4040-8265-47F80EE3D405}"/>
               </a:ext>
             </a:extLst>
           </p:cNvPr>
@@ -6299,7 +6299,7 @@
           <p:nvPr/>
         </p:nvPicPr>
         <p:blipFill>
-          <a:blip xmlns:r="http://schemas.openxmlformats.org/officeDocument/2006/relationships" xmlns:a="http://schemas.openxmlformats.org/drawingml/2006/main" r:embed="R490ec314e09f4adc"/>
+          <a:blip xmlns:r="http://schemas.openxmlformats.org/officeDocument/2006/relationships" xmlns:a="http://schemas.openxmlformats.org/drawingml/2006/main" r:embed="Raf557ade847241d3"/>
           <a:stretch xmlns:a="http://schemas.openxmlformats.org/drawingml/2006/main"/>
         </p:blipFill>
         <p:spPr>
@@ -6317,7 +6317,7 @@
           <p:cNvPr id="7" name="">
             <a:extLst xmlns:a="http://schemas.openxmlformats.org/drawingml/2006/main">
               <a:ext uri="{FF2B5EF4-FFF2-40B4-BE49-F238E27FC236}">
-                <a16:creationId xmlns:a16="http://schemas.microsoft.com/office/drawing/2014/main" id="{8D12E2C1-A258-4C03-949E-CA2643AFB945}"/>
+                <a16:creationId xmlns:a16="http://schemas.microsoft.com/office/drawing/2014/main" id="{4FDE5091-51D3-4A63-98E3-277237A18D3A}"/>
               </a:ext>
             </a:extLst>
           </p:cNvPr>
@@ -6377,7 +6377,7 @@
     </p:spTree>
     <p:extLst>
       <p:ext uri="{BB962C8B-B14F-4D97-AF65-F5344CB8AC3E}">
-        <p14:creationId xmlns:p14="http://schemas.microsoft.com/office/powerpoint/2010/main" val="650455994"/>
+        <p14:creationId xmlns:p14="http://schemas.microsoft.com/office/powerpoint/2010/main" val="629084230"/>
       </p:ext>
     </p:extLst>
   </p:cSld>
@@ -6408,7 +6408,7 @@
           <p:cNvPr id="8" name="chapter-label">
             <a:extLst xmlns:a="http://schemas.openxmlformats.org/drawingml/2006/main">
               <a:ext uri="{FF2B5EF4-FFF2-40B4-BE49-F238E27FC236}">
-                <a16:creationId xmlns:a16="http://schemas.microsoft.com/office/drawing/2014/main" id="{DEC1B7CF-2C75-4708-814D-493EF5F60CEF}"/>
+                <a16:creationId xmlns:a16="http://schemas.microsoft.com/office/drawing/2014/main" id="{47308592-5361-403C-870C-8895A343489B}"/>
               </a:ext>
             </a:extLst>
           </p:cNvPr>
@@ -6470,7 +6470,7 @@
           <p:cNvPr id="2" name="slide-title">
             <a:extLst xmlns:a="http://schemas.openxmlformats.org/drawingml/2006/main">
               <a:ext uri="{FF2B5EF4-FFF2-40B4-BE49-F238E27FC236}">
-                <a16:creationId xmlns:a16="http://schemas.microsoft.com/office/drawing/2014/main" id="{86CF8944-315F-41D4-93E0-7DD5C1ADCFDB}"/>
+                <a16:creationId xmlns:a16="http://schemas.microsoft.com/office/drawing/2014/main" id="{A08FE589-A0B3-4468-BD7E-1C2D6B63B372}"/>
               </a:ext>
             </a:extLst>
           </p:cNvPr>
@@ -6532,7 +6532,7 @@
           <p:cNvPr id="3" name="footer-rule">
             <a:extLst xmlns:a="http://schemas.openxmlformats.org/drawingml/2006/main">
               <a:ext uri="{FF2B5EF4-FFF2-40B4-BE49-F238E27FC236}">
-                <a16:creationId xmlns:a16="http://schemas.microsoft.com/office/drawing/2014/main" id="{C49B89D7-4A13-4C6E-9D59-7419B89C9CF7}"/>
+                <a16:creationId xmlns:a16="http://schemas.microsoft.com/office/drawing/2014/main" id="{1EE5C48C-E235-49F5-A48B-2F9B4E7C15AE}"/>
               </a:ext>
             </a:extLst>
           </p:cNvPr>
@@ -6563,7 +6563,7 @@
           <p:cNvPr id="4" name="footer-book">
             <a:extLst xmlns:a="http://schemas.openxmlformats.org/drawingml/2006/main">
               <a:ext uri="{FF2B5EF4-FFF2-40B4-BE49-F238E27FC236}">
-                <a16:creationId xmlns:a16="http://schemas.microsoft.com/office/drawing/2014/main" id="{ECB5F8EE-74FA-4DF7-BD55-152976CE9A1A}"/>
+                <a16:creationId xmlns:a16="http://schemas.microsoft.com/office/drawing/2014/main" id="{AB533599-FC25-466D-8D7A-423E4B87D787}"/>
               </a:ext>
             </a:extLst>
           </p:cNvPr>
@@ -6625,7 +6625,7 @@
           <p:cNvPr id="5" name="footer-number">
             <a:extLst xmlns:a="http://schemas.openxmlformats.org/drawingml/2006/main">
               <a:ext uri="{FF2B5EF4-FFF2-40B4-BE49-F238E27FC236}">
-                <a16:creationId xmlns:a16="http://schemas.microsoft.com/office/drawing/2014/main" id="{9CD97D79-84F1-45C4-8CA5-79167E38444C}"/>
+                <a16:creationId xmlns:a16="http://schemas.microsoft.com/office/drawing/2014/main" id="{9B03ED9A-1EF8-4048-A652-E906E5EB9AB6}"/>
               </a:ext>
             </a:extLst>
           </p:cNvPr>
@@ -6691,7 +6691,7 @@
           <p:nvPr/>
         </p:nvPicPr>
         <p:blipFill>
-          <a:blip xmlns:r="http://schemas.openxmlformats.org/officeDocument/2006/relationships" xmlns:a="http://schemas.openxmlformats.org/drawingml/2006/main" r:embed="R8dfde3d547a641be"/>
+          <a:blip xmlns:r="http://schemas.openxmlformats.org/officeDocument/2006/relationships" xmlns:a="http://schemas.openxmlformats.org/drawingml/2006/main" r:embed="Rbea36e53a2c248f8"/>
           <a:stretch xmlns:a="http://schemas.openxmlformats.org/drawingml/2006/main"/>
         </p:blipFill>
         <p:spPr>
@@ -6709,7 +6709,7 @@
           <p:cNvPr id="7" name="">
             <a:extLst xmlns:a="http://schemas.openxmlformats.org/drawingml/2006/main">
               <a:ext uri="{FF2B5EF4-FFF2-40B4-BE49-F238E27FC236}">
-                <a16:creationId xmlns:a16="http://schemas.microsoft.com/office/drawing/2014/main" id="{B8AAEE5A-E8F3-4E0C-877E-346E499F1FC4}"/>
+                <a16:creationId xmlns:a16="http://schemas.microsoft.com/office/drawing/2014/main" id="{EAD4CAA9-6BBB-4591-A943-085BDE540560}"/>
               </a:ext>
             </a:extLst>
           </p:cNvPr>
@@ -6769,7 +6769,7 @@
     </p:spTree>
     <p:extLst>
       <p:ext uri="{BB962C8B-B14F-4D97-AF65-F5344CB8AC3E}">
-        <p14:creationId xmlns:p14="http://schemas.microsoft.com/office/powerpoint/2010/main" val="1781072389"/>
+        <p14:creationId xmlns:p14="http://schemas.microsoft.com/office/powerpoint/2010/main" val="2124512939"/>
       </p:ext>
     </p:extLst>
   </p:cSld>
@@ -6800,7 +6800,7 @@
           <p:cNvPr id="11" name="">
             <a:extLst xmlns:a="http://schemas.openxmlformats.org/drawingml/2006/main">
               <a:ext uri="{FF2B5EF4-FFF2-40B4-BE49-F238E27FC236}">
-                <a16:creationId xmlns:a16="http://schemas.microsoft.com/office/drawing/2014/main" id="{5B585033-A49E-4378-A05D-D8E5D5ACFB7F}"/>
+                <a16:creationId xmlns:a16="http://schemas.microsoft.com/office/drawing/2014/main" id="{93E2736C-9E53-40AA-A6E0-01BC350BA403}"/>
               </a:ext>
             </a:extLst>
           </p:cNvPr>
@@ -6862,7 +6862,7 @@
           <p:cNvPr id="2" name="bullet-mark-1">
             <a:extLst xmlns:a="http://schemas.openxmlformats.org/drawingml/2006/main">
               <a:ext uri="{FF2B5EF4-FFF2-40B4-BE49-F238E27FC236}">
-                <a16:creationId xmlns:a16="http://schemas.microsoft.com/office/drawing/2014/main" id="{775639FD-3597-46D2-9E60-46CB6F28810A}"/>
+                <a16:creationId xmlns:a16="http://schemas.microsoft.com/office/drawing/2014/main" id="{EB9B56C4-3E75-463E-9AB8-1CE84BDD156F}"/>
               </a:ext>
             </a:extLst>
           </p:cNvPr>
@@ -6924,7 +6924,7 @@
           <p:cNvPr id="3" name="bullet-1">
             <a:extLst xmlns:a="http://schemas.openxmlformats.org/drawingml/2006/main">
               <a:ext uri="{FF2B5EF4-FFF2-40B4-BE49-F238E27FC236}">
-                <a16:creationId xmlns:a16="http://schemas.microsoft.com/office/drawing/2014/main" id="{FD48A19F-CFC9-4419-9B5F-AF71BB3B8DCF}"/>
+                <a16:creationId xmlns:a16="http://schemas.microsoft.com/office/drawing/2014/main" id="{6CF99AEF-1CA1-46F6-9A5F-146F9E323369}"/>
               </a:ext>
             </a:extLst>
           </p:cNvPr>
@@ -6986,7 +6986,7 @@
           <p:cNvPr id="4" name="bullet-mark-2">
             <a:extLst xmlns:a="http://schemas.openxmlformats.org/drawingml/2006/main">
               <a:ext uri="{FF2B5EF4-FFF2-40B4-BE49-F238E27FC236}">
-                <a16:creationId xmlns:a16="http://schemas.microsoft.com/office/drawing/2014/main" id="{00DF96AC-2E58-4B99-8660-AA706619A7AB}"/>
+                <a16:creationId xmlns:a16="http://schemas.microsoft.com/office/drawing/2014/main" id="{DD4F1C5B-7D5E-4DDC-ABF3-F1BCC56717D7}"/>
               </a:ext>
             </a:extLst>
           </p:cNvPr>
@@ -7048,7 +7048,7 @@
           <p:cNvPr id="5" name="bullet-2">
             <a:extLst xmlns:a="http://schemas.openxmlformats.org/drawingml/2006/main">
               <a:ext uri="{FF2B5EF4-FFF2-40B4-BE49-F238E27FC236}">
-                <a16:creationId xmlns:a16="http://schemas.microsoft.com/office/drawing/2014/main" id="{195889DD-6E0B-48B8-BE80-AE1821FA1C63}"/>
+                <a16:creationId xmlns:a16="http://schemas.microsoft.com/office/drawing/2014/main" id="{DD636C08-AB69-4498-8384-CB4F78518B8F}"/>
               </a:ext>
             </a:extLst>
           </p:cNvPr>
@@ -7110,7 +7110,7 @@
           <p:cNvPr id="6" name="bullet-mark-3">
             <a:extLst xmlns:a="http://schemas.openxmlformats.org/drawingml/2006/main">
               <a:ext uri="{FF2B5EF4-FFF2-40B4-BE49-F238E27FC236}">
-                <a16:creationId xmlns:a16="http://schemas.microsoft.com/office/drawing/2014/main" id="{9FF661F2-CC8E-4ABE-89CF-FE197D40A41D}"/>
+                <a16:creationId xmlns:a16="http://schemas.microsoft.com/office/drawing/2014/main" id="{DA7ACB78-C7D7-40C4-96D5-3A11F18A4F45}"/>
               </a:ext>
             </a:extLst>
           </p:cNvPr>
@@ -7172,7 +7172,7 @@
           <p:cNvPr id="7" name="bullet-3">
             <a:extLst xmlns:a="http://schemas.openxmlformats.org/drawingml/2006/main">
               <a:ext uri="{FF2B5EF4-FFF2-40B4-BE49-F238E27FC236}">
-                <a16:creationId xmlns:a16="http://schemas.microsoft.com/office/drawing/2014/main" id="{9A9C14BC-B5A9-4F4D-9728-8436BD4A9821}"/>
+                <a16:creationId xmlns:a16="http://schemas.microsoft.com/office/drawing/2014/main" id="{94FB7848-A8A2-46D9-9075-557F563E6087}"/>
               </a:ext>
             </a:extLst>
           </p:cNvPr>
@@ -7234,7 +7234,7 @@
           <p:cNvPr id="8" name="bullet-mark-4">
             <a:extLst xmlns:a="http://schemas.openxmlformats.org/drawingml/2006/main">
               <a:ext uri="{FF2B5EF4-FFF2-40B4-BE49-F238E27FC236}">
-                <a16:creationId xmlns:a16="http://schemas.microsoft.com/office/drawing/2014/main" id="{E0E2D0FD-9522-45CC-8CA4-E6EF24A47DFE}"/>
+                <a16:creationId xmlns:a16="http://schemas.microsoft.com/office/drawing/2014/main" id="{F69AE5E7-3793-48FD-BFE6-FDF8A48A6821}"/>
               </a:ext>
             </a:extLst>
           </p:cNvPr>
@@ -7296,7 +7296,7 @@
           <p:cNvPr id="9" name="bullet-4">
             <a:extLst xmlns:a="http://schemas.openxmlformats.org/drawingml/2006/main">
               <a:ext uri="{FF2B5EF4-FFF2-40B4-BE49-F238E27FC236}">
-                <a16:creationId xmlns:a16="http://schemas.microsoft.com/office/drawing/2014/main" id="{3D738EEF-46A4-407B-B47C-07A4B7AC5F1C}"/>
+                <a16:creationId xmlns:a16="http://schemas.microsoft.com/office/drawing/2014/main" id="{8569F7C1-4BAA-472C-BCC3-68A752BF9E7E}"/>
               </a:ext>
             </a:extLst>
           </p:cNvPr>
@@ -7358,7 +7358,7 @@
           <p:cNvPr id="10" name="">
             <a:extLst xmlns:a="http://schemas.openxmlformats.org/drawingml/2006/main">
               <a:ext uri="{FF2B5EF4-FFF2-40B4-BE49-F238E27FC236}">
-                <a16:creationId xmlns:a16="http://schemas.microsoft.com/office/drawing/2014/main" id="{44C347C8-E8F0-4397-8DAE-14DD07FEF452}"/>
+                <a16:creationId xmlns:a16="http://schemas.microsoft.com/office/drawing/2014/main" id="{28B3EEFB-BA9C-4C90-87AE-FA937B52F9BF}"/>
               </a:ext>
             </a:extLst>
           </p:cNvPr>
@@ -7418,7 +7418,7 @@
     </p:spTree>
     <p:extLst>
       <p:ext uri="{BB962C8B-B14F-4D97-AF65-F5344CB8AC3E}">
-        <p14:creationId xmlns:p14="http://schemas.microsoft.com/office/powerpoint/2010/main" val="618705482"/>
+        <p14:creationId xmlns:p14="http://schemas.microsoft.com/office/powerpoint/2010/main" val="1454797358"/>
       </p:ext>
     </p:extLst>
   </p:cSld>
@@ -7449,7 +7449,7 @@
           <p:cNvPr id="10" name="">
             <a:extLst xmlns:a="http://schemas.openxmlformats.org/drawingml/2006/main">
               <a:ext uri="{FF2B5EF4-FFF2-40B4-BE49-F238E27FC236}">
-                <a16:creationId xmlns:a16="http://schemas.microsoft.com/office/drawing/2014/main" id="{AB761EB7-F9D3-4E9B-A917-F59539629E5F}"/>
+                <a16:creationId xmlns:a16="http://schemas.microsoft.com/office/drawing/2014/main" id="{3E27ADDB-6289-449E-AA07-325162BBB501}"/>
               </a:ext>
             </a:extLst>
           </p:cNvPr>
@@ -7511,7 +7511,7 @@
           <p:cNvPr id="2" name="">
             <a:extLst xmlns:a="http://schemas.openxmlformats.org/drawingml/2006/main">
               <a:ext uri="{FF2B5EF4-FFF2-40B4-BE49-F238E27FC236}">
-                <a16:creationId xmlns:a16="http://schemas.microsoft.com/office/drawing/2014/main" id="{C16915CA-E923-4E8E-BA0E-4A5855C21554}"/>
+                <a16:creationId xmlns:a16="http://schemas.microsoft.com/office/drawing/2014/main" id="{71F57AF1-D46E-419F-B8A8-1C22D08AEB2D}"/>
               </a:ext>
             </a:extLst>
           </p:cNvPr>
@@ -7573,7 +7573,7 @@
           <p:cNvPr id="3" name="big-statement">
             <a:extLst xmlns:a="http://schemas.openxmlformats.org/drawingml/2006/main">
               <a:ext uri="{FF2B5EF4-FFF2-40B4-BE49-F238E27FC236}">
-                <a16:creationId xmlns:a16="http://schemas.microsoft.com/office/drawing/2014/main" id="{221CB7A0-1F87-4F48-A6F2-DE49A8C97FD4}"/>
+                <a16:creationId xmlns:a16="http://schemas.microsoft.com/office/drawing/2014/main" id="{62195DD9-580F-4673-90D8-6D82106297E8}"/>
               </a:ext>
             </a:extLst>
           </p:cNvPr>
@@ -7635,7 +7635,7 @@
           <p:cNvPr id="4" name="bullet-mark-1">
             <a:extLst xmlns:a="http://schemas.openxmlformats.org/drawingml/2006/main">
               <a:ext uri="{FF2B5EF4-FFF2-40B4-BE49-F238E27FC236}">
-                <a16:creationId xmlns:a16="http://schemas.microsoft.com/office/drawing/2014/main" id="{99287AE1-8622-4192-A833-89B00C2261C9}"/>
+                <a16:creationId xmlns:a16="http://schemas.microsoft.com/office/drawing/2014/main" id="{57503279-3A0F-4B31-A3BD-E2AFD7571DB5}"/>
               </a:ext>
             </a:extLst>
           </p:cNvPr>
@@ -7697,7 +7697,7 @@
           <p:cNvPr id="5" name="bullet-1">
             <a:extLst xmlns:a="http://schemas.openxmlformats.org/drawingml/2006/main">
               <a:ext uri="{FF2B5EF4-FFF2-40B4-BE49-F238E27FC236}">
-                <a16:creationId xmlns:a16="http://schemas.microsoft.com/office/drawing/2014/main" id="{1FB48549-DDDA-4F98-BC22-E1C81D18EAED}"/>
+                <a16:creationId xmlns:a16="http://schemas.microsoft.com/office/drawing/2014/main" id="{9D26387C-D6DD-4ECD-8B05-6597450D4CED}"/>
               </a:ext>
             </a:extLst>
           </p:cNvPr>
@@ -7759,7 +7759,7 @@
           <p:cNvPr id="6" name="bullet-mark-2">
             <a:extLst xmlns:a="http://schemas.openxmlformats.org/drawingml/2006/main">
               <a:ext uri="{FF2B5EF4-FFF2-40B4-BE49-F238E27FC236}">
-                <a16:creationId xmlns:a16="http://schemas.microsoft.com/office/drawing/2014/main" id="{48E6FC72-89DC-430E-B95F-1A9160418ACA}"/>
+                <a16:creationId xmlns:a16="http://schemas.microsoft.com/office/drawing/2014/main" id="{9BC60B45-4B06-4FFA-8582-83E03374BC75}"/>
               </a:ext>
             </a:extLst>
           </p:cNvPr>
@@ -7821,7 +7821,7 @@
           <p:cNvPr id="7" name="bullet-2">
             <a:extLst xmlns:a="http://schemas.openxmlformats.org/drawingml/2006/main">
               <a:ext uri="{FF2B5EF4-FFF2-40B4-BE49-F238E27FC236}">
-                <a16:creationId xmlns:a16="http://schemas.microsoft.com/office/drawing/2014/main" id="{9FDAAC9C-EAA6-4372-88AF-4D22CFC0A23C}"/>
+                <a16:creationId xmlns:a16="http://schemas.microsoft.com/office/drawing/2014/main" id="{55F6F76F-756A-4BFB-8EBF-1A6CCEC73E81}"/>
               </a:ext>
             </a:extLst>
           </p:cNvPr>
@@ -7883,7 +7883,7 @@
           <p:cNvPr id="8" name="bullet-mark-3">
             <a:extLst xmlns:a="http://schemas.openxmlformats.org/drawingml/2006/main">
               <a:ext uri="{FF2B5EF4-FFF2-40B4-BE49-F238E27FC236}">
-                <a16:creationId xmlns:a16="http://schemas.microsoft.com/office/drawing/2014/main" id="{9899A4B7-11C5-4F06-8B24-9FE0A24B9300}"/>
+                <a16:creationId xmlns:a16="http://schemas.microsoft.com/office/drawing/2014/main" id="{B7AD97C1-3391-40A8-B667-651CBA7D05D2}"/>
               </a:ext>
             </a:extLst>
           </p:cNvPr>
@@ -7945,7 +7945,7 @@
           <p:cNvPr id="9" name="bullet-3">
             <a:extLst xmlns:a="http://schemas.openxmlformats.org/drawingml/2006/main">
               <a:ext uri="{FF2B5EF4-FFF2-40B4-BE49-F238E27FC236}">
-                <a16:creationId xmlns:a16="http://schemas.microsoft.com/office/drawing/2014/main" id="{3FE76FA7-CD26-477E-A969-5D35DDA843C0}"/>
+                <a16:creationId xmlns:a16="http://schemas.microsoft.com/office/drawing/2014/main" id="{9B8930BD-6E41-4039-A6E6-3FBA2D964765}"/>
               </a:ext>
             </a:extLst>
           </p:cNvPr>
@@ -8005,7 +8005,7 @@
     </p:spTree>
     <p:extLst>
       <p:ext uri="{BB962C8B-B14F-4D97-AF65-F5344CB8AC3E}">
-        <p14:creationId xmlns:p14="http://schemas.microsoft.com/office/powerpoint/2010/main" val="1140631321"/>
+        <p14:creationId xmlns:p14="http://schemas.microsoft.com/office/powerpoint/2010/main" val="670723091"/>
       </p:ext>
     </p:extLst>
   </p:cSld>
@@ -8036,7 +8036,7 @@
           <p:cNvPr id="18" name="chapter-label">
             <a:extLst xmlns:a="http://schemas.openxmlformats.org/drawingml/2006/main">
               <a:ext uri="{FF2B5EF4-FFF2-40B4-BE49-F238E27FC236}">
-                <a16:creationId xmlns:a16="http://schemas.microsoft.com/office/drawing/2014/main" id="{2A5CCC10-1F72-4CB1-8E43-3F1BC6FEA902}"/>
+                <a16:creationId xmlns:a16="http://schemas.microsoft.com/office/drawing/2014/main" id="{E9F30E3C-0FA1-4A8A-A409-98C127F460C4}"/>
               </a:ext>
             </a:extLst>
           </p:cNvPr>
@@ -8098,7 +8098,7 @@
           <p:cNvPr id="2" name="slide-title">
             <a:extLst xmlns:a="http://schemas.openxmlformats.org/drawingml/2006/main">
               <a:ext uri="{FF2B5EF4-FFF2-40B4-BE49-F238E27FC236}">
-                <a16:creationId xmlns:a16="http://schemas.microsoft.com/office/drawing/2014/main" id="{41DE8ED0-D0A1-4C10-9B96-EA8093DC598E}"/>
+                <a16:creationId xmlns:a16="http://schemas.microsoft.com/office/drawing/2014/main" id="{DE6424A0-E865-4338-9CAC-1B34CEFF4A9B}"/>
               </a:ext>
             </a:extLst>
           </p:cNvPr>
@@ -8160,7 +8160,7 @@
           <p:cNvPr id="3" name="footer-rule">
             <a:extLst xmlns:a="http://schemas.openxmlformats.org/drawingml/2006/main">
               <a:ext uri="{FF2B5EF4-FFF2-40B4-BE49-F238E27FC236}">
-                <a16:creationId xmlns:a16="http://schemas.microsoft.com/office/drawing/2014/main" id="{12AC5D72-7D6C-4182-949E-3EFB8FA744DD}"/>
+                <a16:creationId xmlns:a16="http://schemas.microsoft.com/office/drawing/2014/main" id="{C666233A-C66D-4228-B849-9AF8BF9903F0}"/>
               </a:ext>
             </a:extLst>
           </p:cNvPr>
@@ -8191,7 +8191,7 @@
           <p:cNvPr id="4" name="footer-book">
             <a:extLst xmlns:a="http://schemas.openxmlformats.org/drawingml/2006/main">
               <a:ext uri="{FF2B5EF4-FFF2-40B4-BE49-F238E27FC236}">
-                <a16:creationId xmlns:a16="http://schemas.microsoft.com/office/drawing/2014/main" id="{14A6E291-0D8A-40AC-9FD1-1E92B10246BA}"/>
+                <a16:creationId xmlns:a16="http://schemas.microsoft.com/office/drawing/2014/main" id="{AE4488A2-593A-459D-AFEB-DADECDD669E7}"/>
               </a:ext>
             </a:extLst>
           </p:cNvPr>
@@ -8253,7 +8253,7 @@
           <p:cNvPr id="5" name="footer-number">
             <a:extLst xmlns:a="http://schemas.openxmlformats.org/drawingml/2006/main">
               <a:ext uri="{FF2B5EF4-FFF2-40B4-BE49-F238E27FC236}">
-                <a16:creationId xmlns:a16="http://schemas.microsoft.com/office/drawing/2014/main" id="{3734C992-374E-4EBD-89A5-3DEE8A6700FC}"/>
+                <a16:creationId xmlns:a16="http://schemas.microsoft.com/office/drawing/2014/main" id="{B86116B1-01AE-495B-8DFF-436EDFD6FD26}"/>
               </a:ext>
             </a:extLst>
           </p:cNvPr>
@@ -8315,7 +8315,7 @@
           <p:cNvPr id="6" name="">
             <a:extLst xmlns:a="http://schemas.openxmlformats.org/drawingml/2006/main">
               <a:ext uri="{FF2B5EF4-FFF2-40B4-BE49-F238E27FC236}">
-                <a16:creationId xmlns:a16="http://schemas.microsoft.com/office/drawing/2014/main" id="{E5406EB0-4ABF-45DB-A577-6083B391ED49}"/>
+                <a16:creationId xmlns:a16="http://schemas.microsoft.com/office/drawing/2014/main" id="{B724000F-431B-4308-8773-2F9E8B97F6EE}"/>
               </a:ext>
             </a:extLst>
           </p:cNvPr>
@@ -8377,7 +8377,7 @@
           <p:cNvPr id="7" name="bullet-mark-1">
             <a:extLst xmlns:a="http://schemas.openxmlformats.org/drawingml/2006/main">
               <a:ext uri="{FF2B5EF4-FFF2-40B4-BE49-F238E27FC236}">
-                <a16:creationId xmlns:a16="http://schemas.microsoft.com/office/drawing/2014/main" id="{DF0C2D0F-6566-4CF0-9016-BE903587F35F}"/>
+                <a16:creationId xmlns:a16="http://schemas.microsoft.com/office/drawing/2014/main" id="{7B1F3E8B-8EAB-46C7-A3AF-1EC68B44EFF8}"/>
               </a:ext>
             </a:extLst>
           </p:cNvPr>
@@ -8439,7 +8439,7 @@
           <p:cNvPr id="8" name="bullet-1">
             <a:extLst xmlns:a="http://schemas.openxmlformats.org/drawingml/2006/main">
               <a:ext uri="{FF2B5EF4-FFF2-40B4-BE49-F238E27FC236}">
-                <a16:creationId xmlns:a16="http://schemas.microsoft.com/office/drawing/2014/main" id="{20CB8D98-B496-49EE-8E27-BAD84D7E544E}"/>
+                <a16:creationId xmlns:a16="http://schemas.microsoft.com/office/drawing/2014/main" id="{31B5ECA1-ED1D-4A04-915A-F2E171905EC2}"/>
               </a:ext>
             </a:extLst>
           </p:cNvPr>
@@ -8501,7 +8501,7 @@
           <p:cNvPr id="9" name="bullet-mark-2">
             <a:extLst xmlns:a="http://schemas.openxmlformats.org/drawingml/2006/main">
               <a:ext uri="{FF2B5EF4-FFF2-40B4-BE49-F238E27FC236}">
-                <a16:creationId xmlns:a16="http://schemas.microsoft.com/office/drawing/2014/main" id="{DA82A6C0-E686-409C-A2DB-6AA96A94641D}"/>
+                <a16:creationId xmlns:a16="http://schemas.microsoft.com/office/drawing/2014/main" id="{DC5191D0-8DED-4DDA-9515-1DBBA895C72C}"/>
               </a:ext>
             </a:extLst>
           </p:cNvPr>
@@ -8563,7 +8563,7 @@
           <p:cNvPr id="10" name="bullet-2">
             <a:extLst xmlns:a="http://schemas.openxmlformats.org/drawingml/2006/main">
               <a:ext uri="{FF2B5EF4-FFF2-40B4-BE49-F238E27FC236}">
-                <a16:creationId xmlns:a16="http://schemas.microsoft.com/office/drawing/2014/main" id="{72546B3A-462B-45DA-98A5-B743CBF56057}"/>
+                <a16:creationId xmlns:a16="http://schemas.microsoft.com/office/drawing/2014/main" id="{477C7AFC-5F1F-42DD-AA54-DF9258C0D717}"/>
               </a:ext>
             </a:extLst>
           </p:cNvPr>
@@ -8625,7 +8625,7 @@
           <p:cNvPr id="11" name="bullet-mark-3">
             <a:extLst xmlns:a="http://schemas.openxmlformats.org/drawingml/2006/main">
               <a:ext uri="{FF2B5EF4-FFF2-40B4-BE49-F238E27FC236}">
-                <a16:creationId xmlns:a16="http://schemas.microsoft.com/office/drawing/2014/main" id="{6A3FFB4A-4CD4-4697-925F-8937912BE6B3}"/>
+                <a16:creationId xmlns:a16="http://schemas.microsoft.com/office/drawing/2014/main" id="{C8F05EC7-D865-4CF6-8BD2-2CA93AB15243}"/>
               </a:ext>
             </a:extLst>
           </p:cNvPr>
@@ -8687,7 +8687,7 @@
           <p:cNvPr id="12" name="bullet-3">
             <a:extLst xmlns:a="http://schemas.openxmlformats.org/drawingml/2006/main">
               <a:ext uri="{FF2B5EF4-FFF2-40B4-BE49-F238E27FC236}">
-                <a16:creationId xmlns:a16="http://schemas.microsoft.com/office/drawing/2014/main" id="{A6786AD3-D590-4633-97C8-CCAF040B1001}"/>
+                <a16:creationId xmlns:a16="http://schemas.microsoft.com/office/drawing/2014/main" id="{C0943632-125E-45F3-A6A7-1CBA2DB16EE0}"/>
               </a:ext>
             </a:extLst>
           </p:cNvPr>
@@ -8749,7 +8749,7 @@
           <p:cNvPr id="13" name="bullet-mark-4">
             <a:extLst xmlns:a="http://schemas.openxmlformats.org/drawingml/2006/main">
               <a:ext uri="{FF2B5EF4-FFF2-40B4-BE49-F238E27FC236}">
-                <a16:creationId xmlns:a16="http://schemas.microsoft.com/office/drawing/2014/main" id="{45F716F9-DF58-4D72-8063-85E53F3C340B}"/>
+                <a16:creationId xmlns:a16="http://schemas.microsoft.com/office/drawing/2014/main" id="{2CE44E6E-F199-4D4D-8AD8-341149AB55CB}"/>
               </a:ext>
             </a:extLst>
           </p:cNvPr>
@@ -8811,7 +8811,7 @@
           <p:cNvPr id="14" name="bullet-4">
             <a:extLst xmlns:a="http://schemas.openxmlformats.org/drawingml/2006/main">
               <a:ext uri="{FF2B5EF4-FFF2-40B4-BE49-F238E27FC236}">
-                <a16:creationId xmlns:a16="http://schemas.microsoft.com/office/drawing/2014/main" id="{4A43F5FA-7562-40EF-AD30-669D82FCFB27}"/>
+                <a16:creationId xmlns:a16="http://schemas.microsoft.com/office/drawing/2014/main" id="{13B0A158-8C5C-40B7-B9AA-E37EE775383D}"/>
               </a:ext>
             </a:extLst>
           </p:cNvPr>
@@ -8873,7 +8873,7 @@
           <p:cNvPr id="15" name="bullet-mark-5">
             <a:extLst xmlns:a="http://schemas.openxmlformats.org/drawingml/2006/main">
               <a:ext uri="{FF2B5EF4-FFF2-40B4-BE49-F238E27FC236}">
-                <a16:creationId xmlns:a16="http://schemas.microsoft.com/office/drawing/2014/main" id="{11DC17D1-A045-4E2D-BE6E-32B4930B1A64}"/>
+                <a16:creationId xmlns:a16="http://schemas.microsoft.com/office/drawing/2014/main" id="{820FB0C5-BC83-4B1F-BDCA-CD0FB31B7152}"/>
               </a:ext>
             </a:extLst>
           </p:cNvPr>
@@ -8935,7 +8935,7 @@
           <p:cNvPr id="16" name="bullet-5">
             <a:extLst xmlns:a="http://schemas.openxmlformats.org/drawingml/2006/main">
               <a:ext uri="{FF2B5EF4-FFF2-40B4-BE49-F238E27FC236}">
-                <a16:creationId xmlns:a16="http://schemas.microsoft.com/office/drawing/2014/main" id="{F8EAE7D0-8F68-4A2E-ABD3-8FE7FF6CFD73}"/>
+                <a16:creationId xmlns:a16="http://schemas.microsoft.com/office/drawing/2014/main" id="{49A5E209-88C8-4F8F-BAB7-35DB8BD77070}"/>
               </a:ext>
             </a:extLst>
           </p:cNvPr>
@@ -8997,7 +8997,7 @@
           <p:cNvPr id="17" name="">
             <a:extLst xmlns:a="http://schemas.openxmlformats.org/drawingml/2006/main">
               <a:ext uri="{FF2B5EF4-FFF2-40B4-BE49-F238E27FC236}">
-                <a16:creationId xmlns:a16="http://schemas.microsoft.com/office/drawing/2014/main" id="{6C0383E1-9E91-4915-A583-BC6108926EFC}"/>
+                <a16:creationId xmlns:a16="http://schemas.microsoft.com/office/drawing/2014/main" id="{A6D00178-7D5D-4CDF-93B4-69C1B7123150}"/>
               </a:ext>
             </a:extLst>
           </p:cNvPr>
@@ -9057,7 +9057,7 @@
     </p:spTree>
     <p:extLst>
       <p:ext uri="{BB962C8B-B14F-4D97-AF65-F5344CB8AC3E}">
-        <p14:creationId xmlns:p14="http://schemas.microsoft.com/office/powerpoint/2010/main" val="1861639413"/>
+        <p14:creationId xmlns:p14="http://schemas.microsoft.com/office/powerpoint/2010/main" val="43648688"/>
       </p:ext>
     </p:extLst>
   </p:cSld>
@@ -9088,7 +9088,7 @@
           <p:cNvPr id="8" name="chapter-label">
             <a:extLst xmlns:a="http://schemas.openxmlformats.org/drawingml/2006/main">
               <a:ext uri="{FF2B5EF4-FFF2-40B4-BE49-F238E27FC236}">
-                <a16:creationId xmlns:a16="http://schemas.microsoft.com/office/drawing/2014/main" id="{877BBF63-6C9A-4EF2-BA08-99B937C7007E}"/>
+                <a16:creationId xmlns:a16="http://schemas.microsoft.com/office/drawing/2014/main" id="{49BCA132-84EA-4615-A6DA-AA5D98000319}"/>
               </a:ext>
             </a:extLst>
           </p:cNvPr>
@@ -9150,7 +9150,7 @@
           <p:cNvPr id="2" name="slide-title">
             <a:extLst xmlns:a="http://schemas.openxmlformats.org/drawingml/2006/main">
               <a:ext uri="{FF2B5EF4-FFF2-40B4-BE49-F238E27FC236}">
-                <a16:creationId xmlns:a16="http://schemas.microsoft.com/office/drawing/2014/main" id="{7489C4E3-FDDE-4F54-A2F7-23C9E77D3847}"/>
+                <a16:creationId xmlns:a16="http://schemas.microsoft.com/office/drawing/2014/main" id="{BD819048-5CE9-4729-8380-52ECF98B1812}"/>
               </a:ext>
             </a:extLst>
           </p:cNvPr>
@@ -9212,7 +9212,7 @@
           <p:cNvPr id="3" name="footer-rule">
             <a:extLst xmlns:a="http://schemas.openxmlformats.org/drawingml/2006/main">
               <a:ext uri="{FF2B5EF4-FFF2-40B4-BE49-F238E27FC236}">
-                <a16:creationId xmlns:a16="http://schemas.microsoft.com/office/drawing/2014/main" id="{E427AD8F-5D32-4E0C-BA96-940EBB159EE4}"/>
+                <a16:creationId xmlns:a16="http://schemas.microsoft.com/office/drawing/2014/main" id="{58D2E654-57FC-4DB4-A950-BE3BAE1C1B22}"/>
               </a:ext>
             </a:extLst>
           </p:cNvPr>
@@ -9243,7 +9243,7 @@
           <p:cNvPr id="4" name="footer-book">
             <a:extLst xmlns:a="http://schemas.openxmlformats.org/drawingml/2006/main">
               <a:ext uri="{FF2B5EF4-FFF2-40B4-BE49-F238E27FC236}">
-                <a16:creationId xmlns:a16="http://schemas.microsoft.com/office/drawing/2014/main" id="{808D7BBE-3427-43DC-ABD3-76ABEFA48585}"/>
+                <a16:creationId xmlns:a16="http://schemas.microsoft.com/office/drawing/2014/main" id="{425B53D7-6E02-4723-85B6-E7BE53EC48AF}"/>
               </a:ext>
             </a:extLst>
           </p:cNvPr>
@@ -9305,7 +9305,7 @@
           <p:cNvPr id="5" name="footer-number">
             <a:extLst xmlns:a="http://schemas.openxmlformats.org/drawingml/2006/main">
               <a:ext uri="{FF2B5EF4-FFF2-40B4-BE49-F238E27FC236}">
-                <a16:creationId xmlns:a16="http://schemas.microsoft.com/office/drawing/2014/main" id="{755DFF87-40DF-46CF-B4B9-97B8C30D6800}"/>
+                <a16:creationId xmlns:a16="http://schemas.microsoft.com/office/drawing/2014/main" id="{F7C6BD07-F21B-4637-BE8C-3C4D91836463}"/>
               </a:ext>
             </a:extLst>
           </p:cNvPr>
@@ -9371,7 +9371,7 @@
           <p:nvPr/>
         </p:nvPicPr>
         <p:blipFill>
-          <a:blip xmlns:r="http://schemas.openxmlformats.org/officeDocument/2006/relationships" xmlns:a="http://schemas.openxmlformats.org/drawingml/2006/main" r:embed="R9b9743f1bc0d4999"/>
+          <a:blip xmlns:r="http://schemas.openxmlformats.org/officeDocument/2006/relationships" xmlns:a="http://schemas.openxmlformats.org/drawingml/2006/main" r:embed="R592cd56254024dab"/>
           <a:stretch xmlns:a="http://schemas.openxmlformats.org/drawingml/2006/main"/>
         </p:blipFill>
         <p:spPr>
@@ -9389,7 +9389,7 @@
           <p:cNvPr id="7" name="">
             <a:extLst xmlns:a="http://schemas.openxmlformats.org/drawingml/2006/main">
               <a:ext uri="{FF2B5EF4-FFF2-40B4-BE49-F238E27FC236}">
-                <a16:creationId xmlns:a16="http://schemas.microsoft.com/office/drawing/2014/main" id="{48B064DD-9687-43E3-9EEB-A915040D77B0}"/>
+                <a16:creationId xmlns:a16="http://schemas.microsoft.com/office/drawing/2014/main" id="{026EA232-447C-4A6E-BB33-C06855390EA1}"/>
               </a:ext>
             </a:extLst>
           </p:cNvPr>
@@ -9449,7 +9449,7 @@
     </p:spTree>
     <p:extLst>
       <p:ext uri="{BB962C8B-B14F-4D97-AF65-F5344CB8AC3E}">
-        <p14:creationId xmlns:p14="http://schemas.microsoft.com/office/powerpoint/2010/main" val="612462610"/>
+        <p14:creationId xmlns:p14="http://schemas.microsoft.com/office/powerpoint/2010/main" val="1791560606"/>
       </p:ext>
     </p:extLst>
   </p:cSld>
@@ -9480,7 +9480,7 @@
           <p:cNvPr id="15" name="chapter-label">
             <a:extLst xmlns:a="http://schemas.openxmlformats.org/drawingml/2006/main">
               <a:ext uri="{FF2B5EF4-FFF2-40B4-BE49-F238E27FC236}">
-                <a16:creationId xmlns:a16="http://schemas.microsoft.com/office/drawing/2014/main" id="{1DD5009C-9CF1-4B43-A568-538FC9EA33FA}"/>
+                <a16:creationId xmlns:a16="http://schemas.microsoft.com/office/drawing/2014/main" id="{DA734F3B-0D3C-4885-B0CB-4CC7AC2CC451}"/>
               </a:ext>
             </a:extLst>
           </p:cNvPr>
@@ -9542,7 +9542,7 @@
           <p:cNvPr id="2" name="slide-title">
             <a:extLst xmlns:a="http://schemas.openxmlformats.org/drawingml/2006/main">
               <a:ext uri="{FF2B5EF4-FFF2-40B4-BE49-F238E27FC236}">
-                <a16:creationId xmlns:a16="http://schemas.microsoft.com/office/drawing/2014/main" id="{6C502309-8675-49B0-BCAC-6223EFB80931}"/>
+                <a16:creationId xmlns:a16="http://schemas.microsoft.com/office/drawing/2014/main" id="{A7F9502A-2E42-4877-BC46-5E71C7CD033A}"/>
               </a:ext>
             </a:extLst>
           </p:cNvPr>
@@ -9604,7 +9604,7 @@
           <p:cNvPr id="3" name="footer-rule">
             <a:extLst xmlns:a="http://schemas.openxmlformats.org/drawingml/2006/main">
               <a:ext uri="{FF2B5EF4-FFF2-40B4-BE49-F238E27FC236}">
-                <a16:creationId xmlns:a16="http://schemas.microsoft.com/office/drawing/2014/main" id="{8A3E8717-A343-45B6-A170-3190816EAD71}"/>
+                <a16:creationId xmlns:a16="http://schemas.microsoft.com/office/drawing/2014/main" id="{3A335858-FA85-4115-8517-5834AB1276ED}"/>
               </a:ext>
             </a:extLst>
           </p:cNvPr>
@@ -9635,7 +9635,7 @@
           <p:cNvPr id="4" name="footer-book">
             <a:extLst xmlns:a="http://schemas.openxmlformats.org/drawingml/2006/main">
               <a:ext uri="{FF2B5EF4-FFF2-40B4-BE49-F238E27FC236}">
-                <a16:creationId xmlns:a16="http://schemas.microsoft.com/office/drawing/2014/main" id="{3F87CE94-753B-451C-BA87-CAF52D4BF9F0}"/>
+                <a16:creationId xmlns:a16="http://schemas.microsoft.com/office/drawing/2014/main" id="{C0CCC5EE-41A8-47A7-B460-0F2C01502A85}"/>
               </a:ext>
             </a:extLst>
           </p:cNvPr>
@@ -9697,7 +9697,7 @@
           <p:cNvPr id="5" name="footer-number">
             <a:extLst xmlns:a="http://schemas.openxmlformats.org/drawingml/2006/main">
               <a:ext uri="{FF2B5EF4-FFF2-40B4-BE49-F238E27FC236}">
-                <a16:creationId xmlns:a16="http://schemas.microsoft.com/office/drawing/2014/main" id="{12BBF57B-C82E-4C32-9E52-DF149483108B}"/>
+                <a16:creationId xmlns:a16="http://schemas.microsoft.com/office/drawing/2014/main" id="{1AED3DC4-B58C-43DE-9418-26A752E25AFD}"/>
               </a:ext>
             </a:extLst>
           </p:cNvPr>
@@ -9759,7 +9759,7 @@
           <p:cNvPr id="6" name="panel-1">
             <a:extLst xmlns:a="http://schemas.openxmlformats.org/drawingml/2006/main">
               <a:ext uri="{FF2B5EF4-FFF2-40B4-BE49-F238E27FC236}">
-                <a16:creationId xmlns:a16="http://schemas.microsoft.com/office/drawing/2014/main" id="{F915B8CF-9D5A-4B54-AEA9-653815B3F3F0}"/>
+                <a16:creationId xmlns:a16="http://schemas.microsoft.com/office/drawing/2014/main" id="{C6C66370-CCCC-429C-8820-612CD266DF03}"/>
               </a:ext>
             </a:extLst>
           </p:cNvPr>
@@ -9792,7 +9792,7 @@
           <p:cNvPr id="7" name="">
             <a:extLst xmlns:a="http://schemas.openxmlformats.org/drawingml/2006/main">
               <a:ext uri="{FF2B5EF4-FFF2-40B4-BE49-F238E27FC236}">
-                <a16:creationId xmlns:a16="http://schemas.microsoft.com/office/drawing/2014/main" id="{83ADDE35-DAE9-435C-B0F8-718B187EA417}"/>
+                <a16:creationId xmlns:a16="http://schemas.microsoft.com/office/drawing/2014/main" id="{8FDACEB1-4812-47C9-9F07-5E49D2BB3507}"/>
               </a:ext>
             </a:extLst>
           </p:cNvPr>
@@ -9854,7 +9854,7 @@
           <p:cNvPr id="8" name="">
             <a:extLst xmlns:a="http://schemas.openxmlformats.org/drawingml/2006/main">
               <a:ext uri="{FF2B5EF4-FFF2-40B4-BE49-F238E27FC236}">
-                <a16:creationId xmlns:a16="http://schemas.microsoft.com/office/drawing/2014/main" id="{D0659063-0C86-4F68-BC31-49A323068C79}"/>
+                <a16:creationId xmlns:a16="http://schemas.microsoft.com/office/drawing/2014/main" id="{9E950925-1B1C-4B79-8AF5-C8BF17EE1E57}"/>
               </a:ext>
             </a:extLst>
           </p:cNvPr>
@@ -9916,7 +9916,7 @@
           <p:cNvPr id="9" name="">
             <a:extLst xmlns:a="http://schemas.openxmlformats.org/drawingml/2006/main">
               <a:ext uri="{FF2B5EF4-FFF2-40B4-BE49-F238E27FC236}">
-                <a16:creationId xmlns:a16="http://schemas.microsoft.com/office/drawing/2014/main" id="{854FD17B-B518-459C-84F3-57CF57D90D9F}"/>
+                <a16:creationId xmlns:a16="http://schemas.microsoft.com/office/drawing/2014/main" id="{E6B55833-FBDF-4ACF-98BA-9A4ECBF4D728}"/>
               </a:ext>
             </a:extLst>
           </p:cNvPr>
@@ -9978,7 +9978,7 @@
           <p:cNvPr id="10" name="panel-2">
             <a:extLst xmlns:a="http://schemas.openxmlformats.org/drawingml/2006/main">
               <a:ext uri="{FF2B5EF4-FFF2-40B4-BE49-F238E27FC236}">
-                <a16:creationId xmlns:a16="http://schemas.microsoft.com/office/drawing/2014/main" id="{B4DF1805-7F97-47A1-80C6-A4D4C18BFF52}"/>
+                <a16:creationId xmlns:a16="http://schemas.microsoft.com/office/drawing/2014/main" id="{526156D2-7853-48C8-9AFE-6828C52F4F11}"/>
               </a:ext>
             </a:extLst>
           </p:cNvPr>
@@ -10011,7 +10011,7 @@
           <p:cNvPr id="11" name="">
             <a:extLst xmlns:a="http://schemas.openxmlformats.org/drawingml/2006/main">
               <a:ext uri="{FF2B5EF4-FFF2-40B4-BE49-F238E27FC236}">
-                <a16:creationId xmlns:a16="http://schemas.microsoft.com/office/drawing/2014/main" id="{B120E512-DC33-4F2E-ACA6-E59FCE8B0986}"/>
+                <a16:creationId xmlns:a16="http://schemas.microsoft.com/office/drawing/2014/main" id="{2994D7AF-4E0F-4A60-8D0D-6C3DEBA4D1AC}"/>
               </a:ext>
             </a:extLst>
           </p:cNvPr>
@@ -10073,7 +10073,7 @@
           <p:cNvPr id="12" name="">
             <a:extLst xmlns:a="http://schemas.openxmlformats.org/drawingml/2006/main">
               <a:ext uri="{FF2B5EF4-FFF2-40B4-BE49-F238E27FC236}">
-                <a16:creationId xmlns:a16="http://schemas.microsoft.com/office/drawing/2014/main" id="{F4C5B520-0B0A-41AB-BFBC-B74F2A8E1E21}"/>
+                <a16:creationId xmlns:a16="http://schemas.microsoft.com/office/drawing/2014/main" id="{F9179A82-83DA-4220-8DCA-E7D489824847}"/>
               </a:ext>
             </a:extLst>
           </p:cNvPr>
@@ -10135,7 +10135,7 @@
           <p:cNvPr id="13" name="">
             <a:extLst xmlns:a="http://schemas.openxmlformats.org/drawingml/2006/main">
               <a:ext uri="{FF2B5EF4-FFF2-40B4-BE49-F238E27FC236}">
-                <a16:creationId xmlns:a16="http://schemas.microsoft.com/office/drawing/2014/main" id="{9801A315-2CE2-403E-B639-69BA7A1C419D}"/>
+                <a16:creationId xmlns:a16="http://schemas.microsoft.com/office/drawing/2014/main" id="{867C3658-CF7B-46B3-9978-46FDF35EBC58}"/>
               </a:ext>
             </a:extLst>
           </p:cNvPr>
@@ -10197,7 +10197,7 @@
           <p:cNvPr id="14" name="">
             <a:extLst xmlns:a="http://schemas.openxmlformats.org/drawingml/2006/main">
               <a:ext uri="{FF2B5EF4-FFF2-40B4-BE49-F238E27FC236}">
-                <a16:creationId xmlns:a16="http://schemas.microsoft.com/office/drawing/2014/main" id="{34B80109-F334-4D61-8D9C-E6952E823F94}"/>
+                <a16:creationId xmlns:a16="http://schemas.microsoft.com/office/drawing/2014/main" id="{F6833720-A8DE-40A1-B391-7715AFD28427}"/>
               </a:ext>
             </a:extLst>
           </p:cNvPr>
@@ -10257,7 +10257,7 @@
     </p:spTree>
     <p:extLst>
       <p:ext uri="{BB962C8B-B14F-4D97-AF65-F5344CB8AC3E}">
-        <p14:creationId xmlns:p14="http://schemas.microsoft.com/office/powerpoint/2010/main" val="953605604"/>
+        <p14:creationId xmlns:p14="http://schemas.microsoft.com/office/powerpoint/2010/main" val="2105579050"/>
       </p:ext>
     </p:extLst>
   </p:cSld>
@@ -10288,7 +10288,7 @@
           <p:cNvPr id="31" name="chapter-label">
             <a:extLst xmlns:a="http://schemas.openxmlformats.org/drawingml/2006/main">
               <a:ext uri="{FF2B5EF4-FFF2-40B4-BE49-F238E27FC236}">
-                <a16:creationId xmlns:a16="http://schemas.microsoft.com/office/drawing/2014/main" id="{5FDF751E-82B0-4663-B136-0D7BEBF1E054}"/>
+                <a16:creationId xmlns:a16="http://schemas.microsoft.com/office/drawing/2014/main" id="{6D777AFD-F7F3-470F-953D-414075820E5C}"/>
               </a:ext>
             </a:extLst>
           </p:cNvPr>
@@ -10350,7 +10350,7 @@
           <p:cNvPr id="2" name="slide-title">
             <a:extLst xmlns:a="http://schemas.openxmlformats.org/drawingml/2006/main">
               <a:ext uri="{FF2B5EF4-FFF2-40B4-BE49-F238E27FC236}">
-                <a16:creationId xmlns:a16="http://schemas.microsoft.com/office/drawing/2014/main" id="{0DF30151-BA09-4C6F-A5EF-6046A6FF73BD}"/>
+                <a16:creationId xmlns:a16="http://schemas.microsoft.com/office/drawing/2014/main" id="{3B6CD702-BB92-4C0C-A25A-370356EEE061}"/>
               </a:ext>
             </a:extLst>
           </p:cNvPr>
@@ -10412,7 +10412,7 @@
           <p:cNvPr id="3" name="footer-rule">
             <a:extLst xmlns:a="http://schemas.openxmlformats.org/drawingml/2006/main">
               <a:ext uri="{FF2B5EF4-FFF2-40B4-BE49-F238E27FC236}">
-                <a16:creationId xmlns:a16="http://schemas.microsoft.com/office/drawing/2014/main" id="{1AEEA7FE-6CDB-4D42-9F99-C8D40011083C}"/>
+                <a16:creationId xmlns:a16="http://schemas.microsoft.com/office/drawing/2014/main" id="{56F6F2C5-FDB6-413B-94D6-9A2F696DB343}"/>
               </a:ext>
             </a:extLst>
           </p:cNvPr>
@@ -10443,7 +10443,7 @@
           <p:cNvPr id="4" name="footer-book">
             <a:extLst xmlns:a="http://schemas.openxmlformats.org/drawingml/2006/main">
               <a:ext uri="{FF2B5EF4-FFF2-40B4-BE49-F238E27FC236}">
-                <a16:creationId xmlns:a16="http://schemas.microsoft.com/office/drawing/2014/main" id="{AAAC2346-0B21-4833-AE1F-AF970D636E80}"/>
+                <a16:creationId xmlns:a16="http://schemas.microsoft.com/office/drawing/2014/main" id="{BC878D85-9BA6-45F6-A92D-2550CA2F53D3}"/>
               </a:ext>
             </a:extLst>
           </p:cNvPr>
@@ -10505,7 +10505,7 @@
           <p:cNvPr id="5" name="footer-number">
             <a:extLst xmlns:a="http://schemas.openxmlformats.org/drawingml/2006/main">
               <a:ext uri="{FF2B5EF4-FFF2-40B4-BE49-F238E27FC236}">
-                <a16:creationId xmlns:a16="http://schemas.microsoft.com/office/drawing/2014/main" id="{2BAC872A-0D7A-46EA-B8BA-8A3585F3F504}"/>
+                <a16:creationId xmlns:a16="http://schemas.microsoft.com/office/drawing/2014/main" id="{18CCA0B1-AC6B-47CA-9E5B-7D2479CE4558}"/>
               </a:ext>
             </a:extLst>
           </p:cNvPr>
@@ -10567,7 +10567,7 @@
           <p:cNvPr id="6" name="">
             <a:extLst xmlns:a="http://schemas.openxmlformats.org/drawingml/2006/main">
               <a:ext uri="{FF2B5EF4-FFF2-40B4-BE49-F238E27FC236}">
-                <a16:creationId xmlns:a16="http://schemas.microsoft.com/office/drawing/2014/main" id="{E71B6BEC-858C-4353-A83F-3CFC2F8C6AF6}"/>
+                <a16:creationId xmlns:a16="http://schemas.microsoft.com/office/drawing/2014/main" id="{082F33FD-D397-4D34-B969-2E278C815F48}"/>
               </a:ext>
             </a:extLst>
           </p:cNvPr>
@@ -10629,7 +10629,7 @@
           <p:cNvPr id="7" name="step-rule-1">
             <a:extLst xmlns:a="http://schemas.openxmlformats.org/drawingml/2006/main">
               <a:ext uri="{FF2B5EF4-FFF2-40B4-BE49-F238E27FC236}">
-                <a16:creationId xmlns:a16="http://schemas.microsoft.com/office/drawing/2014/main" id="{3B26B0C9-7B0E-4C96-9504-D70E80D77FF4}"/>
+                <a16:creationId xmlns:a16="http://schemas.microsoft.com/office/drawing/2014/main" id="{9F73FCA7-7B32-4C0A-867A-3F2CEDCC4A59}"/>
               </a:ext>
             </a:extLst>
           </p:cNvPr>
@@ -10660,7 +10660,7 @@
           <p:cNvPr id="8" name="">
             <a:extLst xmlns:a="http://schemas.openxmlformats.org/drawingml/2006/main">
               <a:ext uri="{FF2B5EF4-FFF2-40B4-BE49-F238E27FC236}">
-                <a16:creationId xmlns:a16="http://schemas.microsoft.com/office/drawing/2014/main" id="{830322F2-D9F9-4A78-A686-EAD68FFFB41B}"/>
+                <a16:creationId xmlns:a16="http://schemas.microsoft.com/office/drawing/2014/main" id="{5AEBA4FA-14EB-47DC-97B8-D74A7C4F7279}"/>
               </a:ext>
             </a:extLst>
           </p:cNvPr>
@@ -10722,7 +10722,7 @@
           <p:cNvPr id="9" name="">
             <a:extLst xmlns:a="http://schemas.openxmlformats.org/drawingml/2006/main">
               <a:ext uri="{FF2B5EF4-FFF2-40B4-BE49-F238E27FC236}">
-                <a16:creationId xmlns:a16="http://schemas.microsoft.com/office/drawing/2014/main" id="{E54E3728-97E0-4986-9AEB-3769A8388570}"/>
+                <a16:creationId xmlns:a16="http://schemas.microsoft.com/office/drawing/2014/main" id="{5F43FD1A-25DD-46CD-9C71-C9CB745B8007}"/>
               </a:ext>
             </a:extLst>
           </p:cNvPr>
@@ -10784,7 +10784,7 @@
           <p:cNvPr id="10" name="">
             <a:extLst xmlns:a="http://schemas.openxmlformats.org/drawingml/2006/main">
               <a:ext uri="{FF2B5EF4-FFF2-40B4-BE49-F238E27FC236}">
-                <a16:creationId xmlns:a16="http://schemas.microsoft.com/office/drawing/2014/main" id="{54081135-0BC3-4B14-BB4F-A0551F14500F}"/>
+                <a16:creationId xmlns:a16="http://schemas.microsoft.com/office/drawing/2014/main" id="{C375B9E7-3535-4019-9EF0-DAFAD11CD6D7}"/>
               </a:ext>
             </a:extLst>
           </p:cNvPr>
@@ -10846,7 +10846,7 @@
           <p:cNvPr id="11" name="step-rule-2">
             <a:extLst xmlns:a="http://schemas.openxmlformats.org/drawingml/2006/main">
               <a:ext uri="{FF2B5EF4-FFF2-40B4-BE49-F238E27FC236}">
-                <a16:creationId xmlns:a16="http://schemas.microsoft.com/office/drawing/2014/main" id="{572FF6BF-F10F-487F-884C-FE5ADAF7802F}"/>
+                <a16:creationId xmlns:a16="http://schemas.microsoft.com/office/drawing/2014/main" id="{5386B957-E4EF-498D-B2BD-FFBF08AD195A}"/>
               </a:ext>
             </a:extLst>
           </p:cNvPr>
@@ -10877,7 +10877,7 @@
           <p:cNvPr id="12" name="">
             <a:extLst xmlns:a="http://schemas.openxmlformats.org/drawingml/2006/main">
               <a:ext uri="{FF2B5EF4-FFF2-40B4-BE49-F238E27FC236}">
-                <a16:creationId xmlns:a16="http://schemas.microsoft.com/office/drawing/2014/main" id="{D70A725E-5200-41C9-BE42-E1BFDF835879}"/>
+                <a16:creationId xmlns:a16="http://schemas.microsoft.com/office/drawing/2014/main" id="{E1F12391-EFD5-41B5-82F4-A1F761911955}"/>
               </a:ext>
             </a:extLst>
           </p:cNvPr>
@@ -10939,7 +10939,7 @@
           <p:cNvPr id="13" name="">
             <a:extLst xmlns:a="http://schemas.openxmlformats.org/drawingml/2006/main">
               <a:ext uri="{FF2B5EF4-FFF2-40B4-BE49-F238E27FC236}">
-                <a16:creationId xmlns:a16="http://schemas.microsoft.com/office/drawing/2014/main" id="{8E26479E-7F9E-45D9-8E8B-0EDB46F34F48}"/>
+                <a16:creationId xmlns:a16="http://schemas.microsoft.com/office/drawing/2014/main" id="{F2FAFB71-5E5A-4652-93C0-A5B8730CC535}"/>
               </a:ext>
             </a:extLst>
           </p:cNvPr>
@@ -11001,7 +11001,7 @@
           <p:cNvPr id="14" name="">
             <a:extLst xmlns:a="http://schemas.openxmlformats.org/drawingml/2006/main">
               <a:ext uri="{FF2B5EF4-FFF2-40B4-BE49-F238E27FC236}">
-                <a16:creationId xmlns:a16="http://schemas.microsoft.com/office/drawing/2014/main" id="{D1DB0BF3-1F93-44D4-AAB8-956F4314FEAB}"/>
+                <a16:creationId xmlns:a16="http://schemas.microsoft.com/office/drawing/2014/main" id="{DBE3E964-ECCC-4946-B5EA-260F5C4C79D4}"/>
               </a:ext>
             </a:extLst>
           </p:cNvPr>
@@ -11063,7 +11063,7 @@
           <p:cNvPr id="15" name="step-rule-3">
             <a:extLst xmlns:a="http://schemas.openxmlformats.org/drawingml/2006/main">
               <a:ext uri="{FF2B5EF4-FFF2-40B4-BE49-F238E27FC236}">
-                <a16:creationId xmlns:a16="http://schemas.microsoft.com/office/drawing/2014/main" id="{3C3E7166-A080-4C6E-BAE7-DC517F66077F}"/>
+                <a16:creationId xmlns:a16="http://schemas.microsoft.com/office/drawing/2014/main" id="{B0378341-B714-4961-A440-56D01887C304}"/>
               </a:ext>
             </a:extLst>
           </p:cNvPr>
@@ -11094,7 +11094,7 @@
           <p:cNvPr id="16" name="">
             <a:extLst xmlns:a="http://schemas.openxmlformats.org/drawingml/2006/main">
               <a:ext uri="{FF2B5EF4-FFF2-40B4-BE49-F238E27FC236}">
-                <a16:creationId xmlns:a16="http://schemas.microsoft.com/office/drawing/2014/main" id="{2B47EDE6-FEE3-4B42-9003-0C6F1F317100}"/>
+                <a16:creationId xmlns:a16="http://schemas.microsoft.com/office/drawing/2014/main" id="{D16D2A00-FD63-4791-ADD9-A9A14944F8FE}"/>
               </a:ext>
             </a:extLst>
           </p:cNvPr>
@@ -11156,7 +11156,7 @@
           <p:cNvPr id="17" name="">
             <a:extLst xmlns:a="http://schemas.openxmlformats.org/drawingml/2006/main">
               <a:ext uri="{FF2B5EF4-FFF2-40B4-BE49-F238E27FC236}">
-                <a16:creationId xmlns:a16="http://schemas.microsoft.com/office/drawing/2014/main" id="{88F1E87D-A9F8-4B62-BE6D-A3C48B00BF93}"/>
+                <a16:creationId xmlns:a16="http://schemas.microsoft.com/office/drawing/2014/main" id="{79A05280-D58D-406A-9023-A78FEDB2DA22}"/>
               </a:ext>
             </a:extLst>
           </p:cNvPr>
@@ -11218,7 +11218,7 @@
           <p:cNvPr id="18" name="">
             <a:extLst xmlns:a="http://schemas.openxmlformats.org/drawingml/2006/main">
               <a:ext uri="{FF2B5EF4-FFF2-40B4-BE49-F238E27FC236}">
-                <a16:creationId xmlns:a16="http://schemas.microsoft.com/office/drawing/2014/main" id="{410A931C-7207-4E14-850C-86015079E8CD}"/>
+                <a16:creationId xmlns:a16="http://schemas.microsoft.com/office/drawing/2014/main" id="{E117C781-A918-48B0-9715-3CDD65F46A33}"/>
               </a:ext>
             </a:extLst>
           </p:cNvPr>
@@ -11280,7 +11280,7 @@
           <p:cNvPr id="19" name="step-rule-4">
             <a:extLst xmlns:a="http://schemas.openxmlformats.org/drawingml/2006/main">
               <a:ext uri="{FF2B5EF4-FFF2-40B4-BE49-F238E27FC236}">
-                <a16:creationId xmlns:a16="http://schemas.microsoft.com/office/drawing/2014/main" id="{F8B069EA-386F-4CF5-A7CA-C542EE9044F9}"/>
+                <a16:creationId xmlns:a16="http://schemas.microsoft.com/office/drawing/2014/main" id="{72DD7D1B-0849-4BC3-9ACE-D6084910CD18}"/>
               </a:ext>
             </a:extLst>
           </p:cNvPr>
@@ -11311,7 +11311,7 @@
           <p:cNvPr id="20" name="">
             <a:extLst xmlns:a="http://schemas.openxmlformats.org/drawingml/2006/main">
               <a:ext uri="{FF2B5EF4-FFF2-40B4-BE49-F238E27FC236}">
-                <a16:creationId xmlns:a16="http://schemas.microsoft.com/office/drawing/2014/main" id="{B7B5EFC8-4004-4261-B49A-FB187B041271}"/>
+                <a16:creationId xmlns:a16="http://schemas.microsoft.com/office/drawing/2014/main" id="{CE9A73C9-8876-4158-BF8B-C0AFEE165341}"/>
               </a:ext>
             </a:extLst>
           </p:cNvPr>
@@ -11373,7 +11373,7 @@
           <p:cNvPr id="21" name="">
             <a:extLst xmlns:a="http://schemas.openxmlformats.org/drawingml/2006/main">
               <a:ext uri="{FF2B5EF4-FFF2-40B4-BE49-F238E27FC236}">
-                <a16:creationId xmlns:a16="http://schemas.microsoft.com/office/drawing/2014/main" id="{C9A6BD80-E1EA-49EC-BCEA-1924D2ED9D23}"/>
+                <a16:creationId xmlns:a16="http://schemas.microsoft.com/office/drawing/2014/main" id="{67882B5D-C1BB-4EE5-B730-66AB062A1ED1}"/>
               </a:ext>
             </a:extLst>
           </p:cNvPr>
@@ -11435,7 +11435,7 @@
           <p:cNvPr id="22" name="">
             <a:extLst xmlns:a="http://schemas.openxmlformats.org/drawingml/2006/main">
               <a:ext uri="{FF2B5EF4-FFF2-40B4-BE49-F238E27FC236}">
-                <a16:creationId xmlns:a16="http://schemas.microsoft.com/office/drawing/2014/main" id="{F287279E-903B-4B47-8FCB-80A615EEACB6}"/>
+                <a16:creationId xmlns:a16="http://schemas.microsoft.com/office/drawing/2014/main" id="{5B01AD43-4848-48A6-A1C8-89E63A645CCE}"/>
               </a:ext>
             </a:extLst>
           </p:cNvPr>
@@ -11497,7 +11497,7 @@
           <p:cNvPr id="23" name="step-rule-5">
             <a:extLst xmlns:a="http://schemas.openxmlformats.org/drawingml/2006/main">
               <a:ext uri="{FF2B5EF4-FFF2-40B4-BE49-F238E27FC236}">
-                <a16:creationId xmlns:a16="http://schemas.microsoft.com/office/drawing/2014/main" id="{86A45C00-9B6F-4829-BF1F-C83AE1677CC8}"/>
+                <a16:creationId xmlns:a16="http://schemas.microsoft.com/office/drawing/2014/main" id="{82A826B9-81BF-46DF-9ECC-6601040394C0}"/>
               </a:ext>
             </a:extLst>
           </p:cNvPr>
@@ -11528,7 +11528,7 @@
           <p:cNvPr id="24" name="">
             <a:extLst xmlns:a="http://schemas.openxmlformats.org/drawingml/2006/main">
               <a:ext uri="{FF2B5EF4-FFF2-40B4-BE49-F238E27FC236}">
-                <a16:creationId xmlns:a16="http://schemas.microsoft.com/office/drawing/2014/main" id="{4147B7EE-16D8-4698-8B1D-A6F402EBF4E3}"/>
+                <a16:creationId xmlns:a16="http://schemas.microsoft.com/office/drawing/2014/main" id="{605A154D-A3F7-4AFD-8B03-7D100D338936}"/>
               </a:ext>
             </a:extLst>
           </p:cNvPr>
@@ -11590,7 +11590,7 @@
           <p:cNvPr id="25" name="">
             <a:extLst xmlns:a="http://schemas.openxmlformats.org/drawingml/2006/main">
               <a:ext uri="{FF2B5EF4-FFF2-40B4-BE49-F238E27FC236}">
-                <a16:creationId xmlns:a16="http://schemas.microsoft.com/office/drawing/2014/main" id="{C6A6D01C-7CCB-48C4-B51A-F635A06F93C6}"/>
+                <a16:creationId xmlns:a16="http://schemas.microsoft.com/office/drawing/2014/main" id="{06DEDBEF-9AD8-4275-AC48-6EABCED5DC8A}"/>
               </a:ext>
             </a:extLst>
           </p:cNvPr>
@@ -11652,7 +11652,7 @@
           <p:cNvPr id="26" name="">
             <a:extLst xmlns:a="http://schemas.openxmlformats.org/drawingml/2006/main">
               <a:ext uri="{FF2B5EF4-FFF2-40B4-BE49-F238E27FC236}">
-                <a16:creationId xmlns:a16="http://schemas.microsoft.com/office/drawing/2014/main" id="{DE83BCB0-AF47-4AAE-A55E-8B385B031FB5}"/>
+                <a16:creationId xmlns:a16="http://schemas.microsoft.com/office/drawing/2014/main" id="{D020D846-6990-4F5D-AD2C-9FD0F04A1BA8}"/>
               </a:ext>
             </a:extLst>
           </p:cNvPr>
@@ -11714,7 +11714,7 @@
           <p:cNvPr id="27" name="step-rule-6">
             <a:extLst xmlns:a="http://schemas.openxmlformats.org/drawingml/2006/main">
               <a:ext uri="{FF2B5EF4-FFF2-40B4-BE49-F238E27FC236}">
-                <a16:creationId xmlns:a16="http://schemas.microsoft.com/office/drawing/2014/main" id="{8B32F4FE-6060-427A-A025-0EF8B6674A28}"/>
+                <a16:creationId xmlns:a16="http://schemas.microsoft.com/office/drawing/2014/main" id="{BA3C247B-32C6-4205-B063-4F49859877D7}"/>
               </a:ext>
             </a:extLst>
           </p:cNvPr>
@@ -11745,7 +11745,7 @@
           <p:cNvPr id="28" name="">
             <a:extLst xmlns:a="http://schemas.openxmlformats.org/drawingml/2006/main">
               <a:ext uri="{FF2B5EF4-FFF2-40B4-BE49-F238E27FC236}">
-                <a16:creationId xmlns:a16="http://schemas.microsoft.com/office/drawing/2014/main" id="{6C3820B1-5E87-4743-89E2-9B826A3CE2FE}"/>
+                <a16:creationId xmlns:a16="http://schemas.microsoft.com/office/drawing/2014/main" id="{5D170230-5A65-4C7E-8496-DC21E321C5D8}"/>
               </a:ext>
             </a:extLst>
           </p:cNvPr>
@@ -11807,7 +11807,7 @@
           <p:cNvPr id="29" name="">
             <a:extLst xmlns:a="http://schemas.openxmlformats.org/drawingml/2006/main">
               <a:ext uri="{FF2B5EF4-FFF2-40B4-BE49-F238E27FC236}">
-                <a16:creationId xmlns:a16="http://schemas.microsoft.com/office/drawing/2014/main" id="{C416AF6A-C7FC-4F2D-BB85-D2176903CABE}"/>
+                <a16:creationId xmlns:a16="http://schemas.microsoft.com/office/drawing/2014/main" id="{AE3ABA7E-23F0-4341-A7A4-9BD757A3212B}"/>
               </a:ext>
             </a:extLst>
           </p:cNvPr>
@@ -11869,7 +11869,7 @@
           <p:cNvPr id="30" name="">
             <a:extLst xmlns:a="http://schemas.openxmlformats.org/drawingml/2006/main">
               <a:ext uri="{FF2B5EF4-FFF2-40B4-BE49-F238E27FC236}">
-                <a16:creationId xmlns:a16="http://schemas.microsoft.com/office/drawing/2014/main" id="{0FAB10AE-C9EF-4ECE-9BB1-4A850E9C902A}"/>
+                <a16:creationId xmlns:a16="http://schemas.microsoft.com/office/drawing/2014/main" id="{406E2027-6524-4636-9623-4A07687CEEE4}"/>
               </a:ext>
             </a:extLst>
           </p:cNvPr>
@@ -11929,7 +11929,7 @@
     </p:spTree>
     <p:extLst>
       <p:ext uri="{BB962C8B-B14F-4D97-AF65-F5344CB8AC3E}">
-        <p14:creationId xmlns:p14="http://schemas.microsoft.com/office/powerpoint/2010/main" val="1954424271"/>
+        <p14:creationId xmlns:p14="http://schemas.microsoft.com/office/powerpoint/2010/main" val="1199684513"/>
       </p:ext>
     </p:extLst>
   </p:cSld>
@@ -11960,7 +11960,7 @@
           <p:cNvPr id="15" name="chapter-label">
             <a:extLst xmlns:a="http://schemas.openxmlformats.org/drawingml/2006/main">
               <a:ext uri="{FF2B5EF4-FFF2-40B4-BE49-F238E27FC236}">
-                <a16:creationId xmlns:a16="http://schemas.microsoft.com/office/drawing/2014/main" id="{53E76881-55FB-4839-B400-7D314436E466}"/>
+                <a16:creationId xmlns:a16="http://schemas.microsoft.com/office/drawing/2014/main" id="{C72B54B2-CEEA-4DCA-A76F-C96226754D0F}"/>
               </a:ext>
             </a:extLst>
           </p:cNvPr>
@@ -12022,7 +12022,7 @@
           <p:cNvPr id="2" name="slide-title">
             <a:extLst xmlns:a="http://schemas.openxmlformats.org/drawingml/2006/main">
               <a:ext uri="{FF2B5EF4-FFF2-40B4-BE49-F238E27FC236}">
-                <a16:creationId xmlns:a16="http://schemas.microsoft.com/office/drawing/2014/main" id="{246CA74A-00EA-4319-A02A-BEDDA817AE2D}"/>
+                <a16:creationId xmlns:a16="http://schemas.microsoft.com/office/drawing/2014/main" id="{27F6B856-9DB7-4121-935D-230DCE2E82ED}"/>
               </a:ext>
             </a:extLst>
           </p:cNvPr>
@@ -12084,7 +12084,7 @@
           <p:cNvPr id="3" name="footer-rule">
             <a:extLst xmlns:a="http://schemas.openxmlformats.org/drawingml/2006/main">
               <a:ext uri="{FF2B5EF4-FFF2-40B4-BE49-F238E27FC236}">
-                <a16:creationId xmlns:a16="http://schemas.microsoft.com/office/drawing/2014/main" id="{67E39F36-DD26-4FAA-9D9A-2727EEF7AF3D}"/>
+                <a16:creationId xmlns:a16="http://schemas.microsoft.com/office/drawing/2014/main" id="{56372AEC-FF48-411D-B13C-A3483DB1CB71}"/>
               </a:ext>
             </a:extLst>
           </p:cNvPr>
@@ -12115,7 +12115,7 @@
           <p:cNvPr id="4" name="footer-book">
             <a:extLst xmlns:a="http://schemas.openxmlformats.org/drawingml/2006/main">
               <a:ext uri="{FF2B5EF4-FFF2-40B4-BE49-F238E27FC236}">
-                <a16:creationId xmlns:a16="http://schemas.microsoft.com/office/drawing/2014/main" id="{854ED8EF-5D58-4898-8035-991C195D27EF}"/>
+                <a16:creationId xmlns:a16="http://schemas.microsoft.com/office/drawing/2014/main" id="{7B3864B6-C7CD-44D4-8500-38EC7845B8FB}"/>
               </a:ext>
             </a:extLst>
           </p:cNvPr>
@@ -12177,7 +12177,7 @@
           <p:cNvPr id="5" name="footer-number">
             <a:extLst xmlns:a="http://schemas.openxmlformats.org/drawingml/2006/main">
               <a:ext uri="{FF2B5EF4-FFF2-40B4-BE49-F238E27FC236}">
-                <a16:creationId xmlns:a16="http://schemas.microsoft.com/office/drawing/2014/main" id="{D28A798F-49AC-4F99-9B63-F1563A686729}"/>
+                <a16:creationId xmlns:a16="http://schemas.microsoft.com/office/drawing/2014/main" id="{90CA2F20-198F-4F95-97D7-CD0295F6D504}"/>
               </a:ext>
             </a:extLst>
           </p:cNvPr>
@@ -12239,7 +12239,7 @@
           <p:cNvPr id="6" name="panel-1">
             <a:extLst xmlns:a="http://schemas.openxmlformats.org/drawingml/2006/main">
               <a:ext uri="{FF2B5EF4-FFF2-40B4-BE49-F238E27FC236}">
-                <a16:creationId xmlns:a16="http://schemas.microsoft.com/office/drawing/2014/main" id="{3215E110-9CFF-4006-AF6A-457C52578AF0}"/>
+                <a16:creationId xmlns:a16="http://schemas.microsoft.com/office/drawing/2014/main" id="{4EBE48F3-3BDC-49D1-BFF0-84848FBD80D7}"/>
               </a:ext>
             </a:extLst>
           </p:cNvPr>
@@ -12272,7 +12272,7 @@
           <p:cNvPr id="7" name="">
             <a:extLst xmlns:a="http://schemas.openxmlformats.org/drawingml/2006/main">
               <a:ext uri="{FF2B5EF4-FFF2-40B4-BE49-F238E27FC236}">
-                <a16:creationId xmlns:a16="http://schemas.microsoft.com/office/drawing/2014/main" id="{7C30E854-3D1D-4066-BB14-7DA653A6F75F}"/>
+                <a16:creationId xmlns:a16="http://schemas.microsoft.com/office/drawing/2014/main" id="{413D4E3E-BBF1-4D3A-B9B9-C34F70902B5C}"/>
               </a:ext>
             </a:extLst>
           </p:cNvPr>
@@ -12334,7 +12334,7 @@
           <p:cNvPr id="8" name="">
             <a:extLst xmlns:a="http://schemas.openxmlformats.org/drawingml/2006/main">
               <a:ext uri="{FF2B5EF4-FFF2-40B4-BE49-F238E27FC236}">
-                <a16:creationId xmlns:a16="http://schemas.microsoft.com/office/drawing/2014/main" id="{A11F4442-14A8-4D80-9B9D-727EF27D670D}"/>
+                <a16:creationId xmlns:a16="http://schemas.microsoft.com/office/drawing/2014/main" id="{5D7921ED-689E-4D94-A0F1-DC0F5D7F0626}"/>
               </a:ext>
             </a:extLst>
           </p:cNvPr>
@@ -12396,7 +12396,7 @@
           <p:cNvPr id="9" name="">
             <a:extLst xmlns:a="http://schemas.openxmlformats.org/drawingml/2006/main">
               <a:ext uri="{FF2B5EF4-FFF2-40B4-BE49-F238E27FC236}">
-                <a16:creationId xmlns:a16="http://schemas.microsoft.com/office/drawing/2014/main" id="{2EF3EE19-20EB-4AD6-9426-CFF0535ED88F}"/>
+                <a16:creationId xmlns:a16="http://schemas.microsoft.com/office/drawing/2014/main" id="{11AA25CE-F199-4F99-8125-A4E2EE8813DD}"/>
               </a:ext>
             </a:extLst>
           </p:cNvPr>
@@ -12458,7 +12458,7 @@
           <p:cNvPr id="10" name="panel-2">
             <a:extLst xmlns:a="http://schemas.openxmlformats.org/drawingml/2006/main">
               <a:ext uri="{FF2B5EF4-FFF2-40B4-BE49-F238E27FC236}">
-                <a16:creationId xmlns:a16="http://schemas.microsoft.com/office/drawing/2014/main" id="{884BDF88-D89E-4142-933D-C7750624FF3D}"/>
+                <a16:creationId xmlns:a16="http://schemas.microsoft.com/office/drawing/2014/main" id="{C7ADBDC5-376F-4E5E-BA18-A14800384377}"/>
               </a:ext>
             </a:extLst>
           </p:cNvPr>
@@ -12491,7 +12491,7 @@
           <p:cNvPr id="11" name="">
             <a:extLst xmlns:a="http://schemas.openxmlformats.org/drawingml/2006/main">
               <a:ext uri="{FF2B5EF4-FFF2-40B4-BE49-F238E27FC236}">
-                <a16:creationId xmlns:a16="http://schemas.microsoft.com/office/drawing/2014/main" id="{CCA1307D-2228-49B4-927D-F2CB3A70AA43}"/>
+                <a16:creationId xmlns:a16="http://schemas.microsoft.com/office/drawing/2014/main" id="{BEE44F7A-17E8-4313-A618-40D11EF46CE2}"/>
               </a:ext>
             </a:extLst>
           </p:cNvPr>
@@ -12553,7 +12553,7 @@
           <p:cNvPr id="12" name="">
             <a:extLst xmlns:a="http://schemas.openxmlformats.org/drawingml/2006/main">
               <a:ext uri="{FF2B5EF4-FFF2-40B4-BE49-F238E27FC236}">
-                <a16:creationId xmlns:a16="http://schemas.microsoft.com/office/drawing/2014/main" id="{D35B39ED-53BA-4B1E-B7D2-3611703C0CC8}"/>
+                <a16:creationId xmlns:a16="http://schemas.microsoft.com/office/drawing/2014/main" id="{CF04432A-9FF4-4917-82CC-4F9A8A4CFB86}"/>
               </a:ext>
             </a:extLst>
           </p:cNvPr>
@@ -12615,7 +12615,7 @@
           <p:cNvPr id="13" name="">
             <a:extLst xmlns:a="http://schemas.openxmlformats.org/drawingml/2006/main">
               <a:ext uri="{FF2B5EF4-FFF2-40B4-BE49-F238E27FC236}">
-                <a16:creationId xmlns:a16="http://schemas.microsoft.com/office/drawing/2014/main" id="{6241209B-3601-42A3-BE94-E247C23C703F}"/>
+                <a16:creationId xmlns:a16="http://schemas.microsoft.com/office/drawing/2014/main" id="{C2658781-BC1E-475D-863A-2BD0CE1C6FA4}"/>
               </a:ext>
             </a:extLst>
           </p:cNvPr>
@@ -12677,7 +12677,7 @@
           <p:cNvPr id="14" name="">
             <a:extLst xmlns:a="http://schemas.openxmlformats.org/drawingml/2006/main">
               <a:ext uri="{FF2B5EF4-FFF2-40B4-BE49-F238E27FC236}">
-                <a16:creationId xmlns:a16="http://schemas.microsoft.com/office/drawing/2014/main" id="{34FBD256-C7E1-41C3-AC54-BFCBBBDE379D}"/>
+                <a16:creationId xmlns:a16="http://schemas.microsoft.com/office/drawing/2014/main" id="{4A2FEC9A-339D-417B-9ED2-6CCC7B3DD9F5}"/>
               </a:ext>
             </a:extLst>
           </p:cNvPr>
@@ -12737,7 +12737,7 @@
     </p:spTree>
     <p:extLst>
       <p:ext uri="{BB962C8B-B14F-4D97-AF65-F5344CB8AC3E}">
-        <p14:creationId xmlns:p14="http://schemas.microsoft.com/office/powerpoint/2010/main" val="995440623"/>
+        <p14:creationId xmlns:p14="http://schemas.microsoft.com/office/powerpoint/2010/main" val="1758831524"/>
       </p:ext>
     </p:extLst>
   </p:cSld>
@@ -12768,7 +12768,7 @@
           <p:cNvPr id="10" name="">
             <a:extLst xmlns:a="http://schemas.openxmlformats.org/drawingml/2006/main">
               <a:ext uri="{FF2B5EF4-FFF2-40B4-BE49-F238E27FC236}">
-                <a16:creationId xmlns:a16="http://schemas.microsoft.com/office/drawing/2014/main" id="{47946DCC-65D7-44F9-9BA1-B6A2898350C0}"/>
+                <a16:creationId xmlns:a16="http://schemas.microsoft.com/office/drawing/2014/main" id="{F2882E88-246B-4F2B-8CB4-690DA5626FDA}"/>
               </a:ext>
             </a:extLst>
           </p:cNvPr>
@@ -12830,7 +12830,7 @@
           <p:cNvPr id="2" name="">
             <a:extLst xmlns:a="http://schemas.openxmlformats.org/drawingml/2006/main">
               <a:ext uri="{FF2B5EF4-FFF2-40B4-BE49-F238E27FC236}">
-                <a16:creationId xmlns:a16="http://schemas.microsoft.com/office/drawing/2014/main" id="{A2073D43-C37E-4598-BE2D-2F234E338562}"/>
+                <a16:creationId xmlns:a16="http://schemas.microsoft.com/office/drawing/2014/main" id="{8867EE1D-86F8-45F1-815A-6233E00F89C6}"/>
               </a:ext>
             </a:extLst>
           </p:cNvPr>
@@ -12892,7 +12892,7 @@
           <p:cNvPr id="3" name="big-statement">
             <a:extLst xmlns:a="http://schemas.openxmlformats.org/drawingml/2006/main">
               <a:ext uri="{FF2B5EF4-FFF2-40B4-BE49-F238E27FC236}">
-                <a16:creationId xmlns:a16="http://schemas.microsoft.com/office/drawing/2014/main" id="{7E79FC7D-12AC-48A9-AA24-3CD93CAEA9BC}"/>
+                <a16:creationId xmlns:a16="http://schemas.microsoft.com/office/drawing/2014/main" id="{EDC34B40-B7B9-436D-9441-EEEF5F625078}"/>
               </a:ext>
             </a:extLst>
           </p:cNvPr>
@@ -12954,7 +12954,7 @@
           <p:cNvPr id="4" name="bullet-mark-1">
             <a:extLst xmlns:a="http://schemas.openxmlformats.org/drawingml/2006/main">
               <a:ext uri="{FF2B5EF4-FFF2-40B4-BE49-F238E27FC236}">
-                <a16:creationId xmlns:a16="http://schemas.microsoft.com/office/drawing/2014/main" id="{961C27FC-5D40-4C34-99BB-60B0B3AF9D01}"/>
+                <a16:creationId xmlns:a16="http://schemas.microsoft.com/office/drawing/2014/main" id="{7C8F6054-B923-4C7F-B055-BFBAF1AC4443}"/>
               </a:ext>
             </a:extLst>
           </p:cNvPr>
@@ -13016,7 +13016,7 @@
           <p:cNvPr id="5" name="bullet-1">
             <a:extLst xmlns:a="http://schemas.openxmlformats.org/drawingml/2006/main">
               <a:ext uri="{FF2B5EF4-FFF2-40B4-BE49-F238E27FC236}">
-                <a16:creationId xmlns:a16="http://schemas.microsoft.com/office/drawing/2014/main" id="{75C34FDA-4154-463B-884A-6AEBD7F25A06}"/>
+                <a16:creationId xmlns:a16="http://schemas.microsoft.com/office/drawing/2014/main" id="{65FF9D25-73F1-40BA-B1FC-46084B63D2FD}"/>
               </a:ext>
             </a:extLst>
           </p:cNvPr>
@@ -13078,7 +13078,7 @@
           <p:cNvPr id="6" name="bullet-mark-2">
             <a:extLst xmlns:a="http://schemas.openxmlformats.org/drawingml/2006/main">
               <a:ext uri="{FF2B5EF4-FFF2-40B4-BE49-F238E27FC236}">
-                <a16:creationId xmlns:a16="http://schemas.microsoft.com/office/drawing/2014/main" id="{78EC17FB-BD1F-47E9-9D6F-8FE35A6A98B6}"/>
+                <a16:creationId xmlns:a16="http://schemas.microsoft.com/office/drawing/2014/main" id="{21FDAA5C-223D-4F3A-88DB-EF94F5E8CBDC}"/>
               </a:ext>
             </a:extLst>
           </p:cNvPr>
@@ -13140,7 +13140,7 @@
           <p:cNvPr id="7" name="bullet-2">
             <a:extLst xmlns:a="http://schemas.openxmlformats.org/drawingml/2006/main">
               <a:ext uri="{FF2B5EF4-FFF2-40B4-BE49-F238E27FC236}">
-                <a16:creationId xmlns:a16="http://schemas.microsoft.com/office/drawing/2014/main" id="{BD50037F-5075-4C43-B803-A39936BD761E}"/>
+                <a16:creationId xmlns:a16="http://schemas.microsoft.com/office/drawing/2014/main" id="{B323901D-15FD-4E0C-905A-581ADCB93E51}"/>
               </a:ext>
             </a:extLst>
           </p:cNvPr>
@@ -13202,7 +13202,7 @@
           <p:cNvPr id="8" name="bullet-mark-3">
             <a:extLst xmlns:a="http://schemas.openxmlformats.org/drawingml/2006/main">
               <a:ext uri="{FF2B5EF4-FFF2-40B4-BE49-F238E27FC236}">
-                <a16:creationId xmlns:a16="http://schemas.microsoft.com/office/drawing/2014/main" id="{813437FB-A8BC-491A-9F90-7380EB235EE5}"/>
+                <a16:creationId xmlns:a16="http://schemas.microsoft.com/office/drawing/2014/main" id="{110EAB54-E6B5-425F-BE2D-74B874F8A639}"/>
               </a:ext>
             </a:extLst>
           </p:cNvPr>
@@ -13264,7 +13264,7 @@
           <p:cNvPr id="9" name="bullet-3">
             <a:extLst xmlns:a="http://schemas.openxmlformats.org/drawingml/2006/main">
               <a:ext uri="{FF2B5EF4-FFF2-40B4-BE49-F238E27FC236}">
-                <a16:creationId xmlns:a16="http://schemas.microsoft.com/office/drawing/2014/main" id="{F0BE442E-F8FD-4BAF-ACD1-60FD71F88170}"/>
+                <a16:creationId xmlns:a16="http://schemas.microsoft.com/office/drawing/2014/main" id="{BDD980C3-4200-49E5-8645-E1D41F10B3FF}"/>
               </a:ext>
             </a:extLst>
           </p:cNvPr>
@@ -13324,7 +13324,7 @@
     </p:spTree>
     <p:extLst>
       <p:ext uri="{BB962C8B-B14F-4D97-AF65-F5344CB8AC3E}">
-        <p14:creationId xmlns:p14="http://schemas.microsoft.com/office/powerpoint/2010/main" val="930297328"/>
+        <p14:creationId xmlns:p14="http://schemas.microsoft.com/office/powerpoint/2010/main" val="107407442"/>
       </p:ext>
     </p:extLst>
   </p:cSld>
@@ -13355,7 +13355,7 @@
           <p:cNvPr id="15" name="chapter-label">
             <a:extLst xmlns:a="http://schemas.openxmlformats.org/drawingml/2006/main">
               <a:ext uri="{FF2B5EF4-FFF2-40B4-BE49-F238E27FC236}">
-                <a16:creationId xmlns:a16="http://schemas.microsoft.com/office/drawing/2014/main" id="{9CC3CF7B-3E02-4E44-833E-3163D04071B9}"/>
+                <a16:creationId xmlns:a16="http://schemas.microsoft.com/office/drawing/2014/main" id="{2D519FF3-97C3-4D7E-95C7-14BB192171AD}"/>
               </a:ext>
             </a:extLst>
           </p:cNvPr>
@@ -13417,7 +13417,7 @@
           <p:cNvPr id="2" name="slide-title">
             <a:extLst xmlns:a="http://schemas.openxmlformats.org/drawingml/2006/main">
               <a:ext uri="{FF2B5EF4-FFF2-40B4-BE49-F238E27FC236}">
-                <a16:creationId xmlns:a16="http://schemas.microsoft.com/office/drawing/2014/main" id="{9C33A5AD-9660-4A15-9E0D-7108F166FA7F}"/>
+                <a16:creationId xmlns:a16="http://schemas.microsoft.com/office/drawing/2014/main" id="{B628C721-E7E3-48C0-B42A-56CF1B0BBCF6}"/>
               </a:ext>
             </a:extLst>
           </p:cNvPr>
@@ -13479,7 +13479,7 @@
           <p:cNvPr id="3" name="footer-rule">
             <a:extLst xmlns:a="http://schemas.openxmlformats.org/drawingml/2006/main">
               <a:ext uri="{FF2B5EF4-FFF2-40B4-BE49-F238E27FC236}">
-                <a16:creationId xmlns:a16="http://schemas.microsoft.com/office/drawing/2014/main" id="{EB99877B-1D8F-44BC-BBFE-705E355E834E}"/>
+                <a16:creationId xmlns:a16="http://schemas.microsoft.com/office/drawing/2014/main" id="{D1612E61-5C64-459F-A0C8-929F628B3FC5}"/>
               </a:ext>
             </a:extLst>
           </p:cNvPr>
@@ -13510,7 +13510,7 @@
           <p:cNvPr id="4" name="footer-book">
             <a:extLst xmlns:a="http://schemas.openxmlformats.org/drawingml/2006/main">
               <a:ext uri="{FF2B5EF4-FFF2-40B4-BE49-F238E27FC236}">
-                <a16:creationId xmlns:a16="http://schemas.microsoft.com/office/drawing/2014/main" id="{9F79131A-777E-4882-B660-0FD276D537D9}"/>
+                <a16:creationId xmlns:a16="http://schemas.microsoft.com/office/drawing/2014/main" id="{C0C2ECEF-1DD8-45EC-8244-E31EC08561A7}"/>
               </a:ext>
             </a:extLst>
           </p:cNvPr>
@@ -13572,7 +13572,7 @@
           <p:cNvPr id="5" name="footer-number">
             <a:extLst xmlns:a="http://schemas.openxmlformats.org/drawingml/2006/main">
               <a:ext uri="{FF2B5EF4-FFF2-40B4-BE49-F238E27FC236}">
-                <a16:creationId xmlns:a16="http://schemas.microsoft.com/office/drawing/2014/main" id="{C58F527F-D026-478F-AD6D-840073B372B3}"/>
+                <a16:creationId xmlns:a16="http://schemas.microsoft.com/office/drawing/2014/main" id="{0E0BE87B-3390-4912-9996-7C3B97D960B3}"/>
               </a:ext>
             </a:extLst>
           </p:cNvPr>
@@ -13634,7 +13634,7 @@
           <p:cNvPr id="6" name="panel-1">
             <a:extLst xmlns:a="http://schemas.openxmlformats.org/drawingml/2006/main">
               <a:ext uri="{FF2B5EF4-FFF2-40B4-BE49-F238E27FC236}">
-                <a16:creationId xmlns:a16="http://schemas.microsoft.com/office/drawing/2014/main" id="{B88353B0-B509-4862-AEFA-DC875F3A8A67}"/>
+                <a16:creationId xmlns:a16="http://schemas.microsoft.com/office/drawing/2014/main" id="{CB970544-EBCD-41FF-B260-7D2E9BC5DFB7}"/>
               </a:ext>
             </a:extLst>
           </p:cNvPr>
@@ -13667,7 +13667,7 @@
           <p:cNvPr id="7" name="">
             <a:extLst xmlns:a="http://schemas.openxmlformats.org/drawingml/2006/main">
               <a:ext uri="{FF2B5EF4-FFF2-40B4-BE49-F238E27FC236}">
-                <a16:creationId xmlns:a16="http://schemas.microsoft.com/office/drawing/2014/main" id="{F1F49F73-7CF0-4743-9323-A0BE6BD9812D}"/>
+                <a16:creationId xmlns:a16="http://schemas.microsoft.com/office/drawing/2014/main" id="{4831C386-9F2D-4071-951A-F479968518CD}"/>
               </a:ext>
             </a:extLst>
           </p:cNvPr>
@@ -13729,7 +13729,7 @@
           <p:cNvPr id="8" name="">
             <a:extLst xmlns:a="http://schemas.openxmlformats.org/drawingml/2006/main">
               <a:ext uri="{FF2B5EF4-FFF2-40B4-BE49-F238E27FC236}">
-                <a16:creationId xmlns:a16="http://schemas.microsoft.com/office/drawing/2014/main" id="{72FE2EB2-20A7-4E57-91D7-D73AF42C3A0A}"/>
+                <a16:creationId xmlns:a16="http://schemas.microsoft.com/office/drawing/2014/main" id="{9772CF77-7232-46BA-8197-FDEA93FA3BB4}"/>
               </a:ext>
             </a:extLst>
           </p:cNvPr>
@@ -13791,7 +13791,7 @@
           <p:cNvPr id="9" name="">
             <a:extLst xmlns:a="http://schemas.openxmlformats.org/drawingml/2006/main">
               <a:ext uri="{FF2B5EF4-FFF2-40B4-BE49-F238E27FC236}">
-                <a16:creationId xmlns:a16="http://schemas.microsoft.com/office/drawing/2014/main" id="{B76A2D77-22AC-476B-B661-7BE939A45AAC}"/>
+                <a16:creationId xmlns:a16="http://schemas.microsoft.com/office/drawing/2014/main" id="{9F71F653-564E-4FCC-B2B7-19A9CC727DC5}"/>
               </a:ext>
             </a:extLst>
           </p:cNvPr>
@@ -13853,7 +13853,7 @@
           <p:cNvPr id="10" name="panel-2">
             <a:extLst xmlns:a="http://schemas.openxmlformats.org/drawingml/2006/main">
               <a:ext uri="{FF2B5EF4-FFF2-40B4-BE49-F238E27FC236}">
-                <a16:creationId xmlns:a16="http://schemas.microsoft.com/office/drawing/2014/main" id="{E7EC119E-D199-4E28-9256-921E7F547AE9}"/>
+                <a16:creationId xmlns:a16="http://schemas.microsoft.com/office/drawing/2014/main" id="{8EC2523F-5C52-4E10-90BA-76017435BCA6}"/>
               </a:ext>
             </a:extLst>
           </p:cNvPr>
@@ -13886,7 +13886,7 @@
           <p:cNvPr id="11" name="">
             <a:extLst xmlns:a="http://schemas.openxmlformats.org/drawingml/2006/main">
               <a:ext uri="{FF2B5EF4-FFF2-40B4-BE49-F238E27FC236}">
-                <a16:creationId xmlns:a16="http://schemas.microsoft.com/office/drawing/2014/main" id="{2515810C-AFB0-480D-B721-F9D3EE7ED1E6}"/>
+                <a16:creationId xmlns:a16="http://schemas.microsoft.com/office/drawing/2014/main" id="{3F9DED3F-CFB6-4D29-8B17-348C1728ED1A}"/>
               </a:ext>
             </a:extLst>
           </p:cNvPr>
@@ -13948,7 +13948,7 @@
           <p:cNvPr id="12" name="">
             <a:extLst xmlns:a="http://schemas.openxmlformats.org/drawingml/2006/main">
               <a:ext uri="{FF2B5EF4-FFF2-40B4-BE49-F238E27FC236}">
-                <a16:creationId xmlns:a16="http://schemas.microsoft.com/office/drawing/2014/main" id="{952B95B6-FA6C-4B61-AF3F-68B0F16DEFE8}"/>
+                <a16:creationId xmlns:a16="http://schemas.microsoft.com/office/drawing/2014/main" id="{7436FDC3-0D6C-4D23-9668-F2E6C0572623}"/>
               </a:ext>
             </a:extLst>
           </p:cNvPr>
@@ -14010,7 +14010,7 @@
           <p:cNvPr id="13" name="">
             <a:extLst xmlns:a="http://schemas.openxmlformats.org/drawingml/2006/main">
               <a:ext uri="{FF2B5EF4-FFF2-40B4-BE49-F238E27FC236}">
-                <a16:creationId xmlns:a16="http://schemas.microsoft.com/office/drawing/2014/main" id="{3A2BCA4C-CB6E-45DD-86F2-86CFE4FFECAD}"/>
+                <a16:creationId xmlns:a16="http://schemas.microsoft.com/office/drawing/2014/main" id="{869B337F-A65C-46DC-9CFF-EC0E57B76CB1}"/>
               </a:ext>
             </a:extLst>
           </p:cNvPr>
@@ -14072,7 +14072,7 @@
           <p:cNvPr id="14" name="">
             <a:extLst xmlns:a="http://schemas.openxmlformats.org/drawingml/2006/main">
               <a:ext uri="{FF2B5EF4-FFF2-40B4-BE49-F238E27FC236}">
-                <a16:creationId xmlns:a16="http://schemas.microsoft.com/office/drawing/2014/main" id="{05B65DD1-4CA1-486C-842D-9EBC3E0FAEF2}"/>
+                <a16:creationId xmlns:a16="http://schemas.microsoft.com/office/drawing/2014/main" id="{9526EB48-646F-41E5-84B5-66DA679C9BC1}"/>
               </a:ext>
             </a:extLst>
           </p:cNvPr>
@@ -14132,7 +14132,7 @@
     </p:spTree>
     <p:extLst>
       <p:ext uri="{BB962C8B-B14F-4D97-AF65-F5344CB8AC3E}">
-        <p14:creationId xmlns:p14="http://schemas.microsoft.com/office/powerpoint/2010/main" val="44174109"/>
+        <p14:creationId xmlns:p14="http://schemas.microsoft.com/office/powerpoint/2010/main" val="759447175"/>
       </p:ext>
     </p:extLst>
   </p:cSld>

</xml_diff>